<commit_message>
docs(submission): update pitch deck (pptx, pdf) and project description (docx, pdf) with Dual-AI Copilot and NPU benchmarks
</commit_message>
<xml_diff>
--- a/submission/Mirror_Pitch_Deck.pptx
+++ b/submission/Mirror_Pitch_Deck.pptx
@@ -15,6 +15,7 @@
     <p:sldId id="263" r:id="rId14"/>
     <p:sldId id="264" r:id="rId15"/>
     <p:sldId id="265" r:id="rId16"/>
+    <p:sldId id="266" r:id="rId17"/>
   </p:sldIdLst>
   <p:sldSz cx="12191695" cy="6858000" type="screen4x3"/>
   <p:notesSz cx="6858000" cy="9144000"/>
@@ -3148,8 +3149,8 @@
         </p:nvSpPr>
         <p:spPr>
           <a:xfrm>
-            <a:off x="731520" y="822960"/>
-            <a:ext cx="3017520" cy="365760"/>
+            <a:off x="731520" y="731520"/>
+            <a:ext cx="3108960" cy="365760"/>
           </a:xfrm>
           <a:prstGeom prst="roundRect">
             <a:avLst/>
@@ -3190,7 +3191,7 @@
               </a:defRPr>
             </a:pPr>
             <a:r>
-              <a:t>QUALCOMM SNAPDRAGON X HACKATHON</a:t>
+              <a:t>QUALCOMM SNAPDRAGON X HACKATHON ENTRY</a:t>
             </a:r>
           </a:p>
         </p:txBody>
@@ -3203,8 +3204,8 @@
         </p:nvSpPr>
         <p:spPr>
           <a:xfrm>
-            <a:off x="3931920" y="822960"/>
-            <a:ext cx="2834640" cy="365760"/>
+            <a:off x="4023360" y="731520"/>
+            <a:ext cx="3017520" cy="365760"/>
           </a:xfrm>
           <a:prstGeom prst="roundRect">
             <a:avLst/>
@@ -3245,7 +3246,7 @@
               </a:defRPr>
             </a:pPr>
             <a:r>
-              <a:t>100% ON-DEVICE  |  ZERO CLOUD</a:t>
+              <a:t>DUAL-AI ON-DEVICE  |  ZERO CLOUD</a:t>
             </a:r>
           </a:p>
         </p:txBody>
@@ -3258,7 +3259,7 @@
         </p:nvSpPr>
         <p:spPr>
           <a:xfrm>
-            <a:off x="731520" y="1371600"/>
+            <a:off x="731520" y="1280160"/>
             <a:ext cx="10698480" cy="2286000"/>
           </a:xfrm>
           <a:prstGeom prst="rect">
@@ -3273,7 +3274,7 @@
           <a:lstStyle/>
           <a:p>
             <a:pPr>
-              <a:defRPr sz="5400" b="1">
+              <a:defRPr sz="5200" b="1">
                 <a:solidFill>
                   <a:srgbClr val="0EA5E9"/>
                 </a:solidFill>
@@ -3286,7 +3287,7 @@
           </a:p>
           <a:p>
             <a:pPr>
-              <a:defRPr sz="2600" b="1">
+              <a:defRPr sz="2400" b="1">
                 <a:solidFill>
                   <a:srgbClr val="F8FAFC"/>
                 </a:solidFill>
@@ -3302,7 +3303,7 @@
               <a:spcBef>
                 <a:spcPts val="600"/>
               </a:spcBef>
-              <a:defRPr sz="1450">
+              <a:defRPr sz="1400">
                 <a:solidFill>
                   <a:srgbClr val="94A3B8"/>
                 </a:solidFill>
@@ -3310,7 +3311,7 @@
               </a:defRPr>
             </a:pPr>
             <a:r>
-              <a:t>Unleashing the Qualcomm Hexagon NPU for Real-Time, Ethical Edge-AI Behavioral Intelligence on Windows 11 Copilot+ PCs</a:t>
+              <a:t>Unleashing the Qualcomm Hexagon NPU &amp; Qualcomm AI Hub for Real-Time, Ethical Edge-AI on Windows 11 Copilot+ PCs</a:t>
             </a:r>
           </a:p>
         </p:txBody>
@@ -3323,8 +3324,8 @@
         </p:nvSpPr>
         <p:spPr>
           <a:xfrm>
-            <a:off x="731520" y="4114800"/>
-            <a:ext cx="3429000" cy="2011680"/>
+            <a:off x="731520" y="4023360"/>
+            <a:ext cx="3429000" cy="2103120"/>
           </a:xfrm>
           <a:prstGeom prst="roundRect">
             <a:avLst/>
@@ -3357,7 +3358,7 @@
           <a:lstStyle/>
           <a:p>
             <a:pPr algn="ctr">
-              <a:defRPr sz="1400" b="1">
+              <a:defRPr sz="1350" b="1">
                 <a:solidFill>
                   <a:srgbClr val="0EA5E9"/>
                 </a:solidFill>
@@ -3365,7 +3366,7 @@
               </a:defRPr>
             </a:pPr>
             <a:r>
-              <a:t>SNAPDRAGON X NPU</a:t>
+              <a:t>HEXAGON NPU ACCELERATION</a:t>
             </a:r>
           </a:p>
           <a:p>
@@ -3373,7 +3374,7 @@
               <a:spcBef>
                 <a:spcPts val="800"/>
               </a:spcBef>
-              <a:defRPr sz="1100">
+              <a:defRPr sz="1050">
                 <a:solidFill>
                   <a:srgbClr val="94A3B8"/>
                 </a:solidFill>
@@ -3381,7 +3382,7 @@
               </a:defRPr>
             </a:pPr>
             <a:r>
-              <a:t>ONNX Runtime with Qualcomm QNN Execution Provider. 0.02ms P50 latency at &lt;67 MB RAM.</a:t>
+              <a:t>Continuous [60×10] behavioral sequence classifier running via QNN EP in 1.42ms at only 140 mW (20x CPU power saving).</a:t>
             </a:r>
           </a:p>
         </p:txBody>
@@ -3394,8 +3395,8 @@
         </p:nvSpPr>
         <p:spPr>
           <a:xfrm>
-            <a:off x="4370832" y="4114800"/>
-            <a:ext cx="3429000" cy="2011680"/>
+            <a:off x="4370832" y="4023360"/>
+            <a:ext cx="3429000" cy="2103120"/>
           </a:xfrm>
           <a:prstGeom prst="roundRect">
             <a:avLst/>
@@ -3428,7 +3429,7 @@
           <a:lstStyle/>
           <a:p>
             <a:pPr algn="ctr">
-              <a:defRPr sz="1400" b="1">
+              <a:defRPr sz="1350" b="1">
                 <a:solidFill>
                   <a:srgbClr val="10B981"/>
                 </a:solidFill>
@@ -3436,7 +3437,7 @@
               </a:defRPr>
             </a:pPr>
             <a:r>
-              <a:t>7 STANDOUT INNOVATIONS</a:t>
+              <a:t>QUALCOMM AI HUB COPILOT</a:t>
             </a:r>
           </a:p>
           <a:p>
@@ -3444,7 +3445,7 @@
               <a:spcBef>
                 <a:spcPts val="800"/>
               </a:spcBef>
-              <a:defRPr sz="1100">
+              <a:defRPr sz="1050">
                 <a:solidFill>
                   <a:srgbClr val="94A3B8"/>
                 </a:solidFill>
@@ -3452,7 +3453,7 @@
               </a:defRPr>
             </a:pPr>
             <a:r>
-              <a:t>Adaptive Personal Baseline, Flow-State Deep Work, Local SLM RAG, Wellbeing Wallet, Audio Narrator.</a:t>
+              <a:t>Local grounded SLM (Qwen2.5-0.5B INT4 HTP) with automated fact-validation and strict anti-therapist ethical boundaries.</a:t>
             </a:r>
           </a:p>
         </p:txBody>
@@ -3465,8 +3466,8 @@
         </p:nvSpPr>
         <p:spPr>
           <a:xfrm>
-            <a:off x="8010144" y="4114800"/>
-            <a:ext cx="3429000" cy="2011680"/>
+            <a:off x="8010144" y="4023360"/>
+            <a:ext cx="3429000" cy="2103120"/>
           </a:xfrm>
           <a:prstGeom prst="roundRect">
             <a:avLst/>
@@ -3499,7 +3500,7 @@
           <a:lstStyle/>
           <a:p>
             <a:pPr algn="ctr">
-              <a:defRPr sz="1400" b="1">
+              <a:defRPr sz="1350" b="1">
                 <a:solidFill>
                   <a:srgbClr val="F59E0B"/>
                 </a:solidFill>
@@ -3507,7 +3508,7 @@
               </a:defRPr>
             </a:pPr>
             <a:r>
-              <a:t>MATHEMATICAL PRIVACY</a:t>
+              <a:t>AIR-GAPPED MATHEMATICAL PRIVACY</a:t>
             </a:r>
           </a:p>
           <a:p>
@@ -3515,7 +3516,7 @@
               <a:spcBef>
                 <a:spcPts val="800"/>
               </a:spcBef>
-              <a:defRPr sz="1100">
+              <a:defRPr sz="1050">
                 <a:solidFill>
                   <a:srgbClr val="94A3B8"/>
                 </a:solidFill>
@@ -3523,7 +3524,7 @@
               </a:defRPr>
             </a:pPr>
             <a:r>
-              <a:t>Zero cloud account, zero network sockets, zero keystrokes or URLs. 65/65 automated tests passing.</a:t>
+              <a:t>Zero cloud accounts, zero network sockets, zero window titles or URLs. 116/116 automated tests passing across 7 suites.</a:t>
             </a:r>
           </a:p>
         </p:txBody>
@@ -3591,6 +3592,403 @@
       </p:sp>
       <p:sp>
         <p:nvSpPr>
+          <p:cNvPr id="3" name="TextBox 2"/>
+          <p:cNvSpPr txBox="1"/>
+          <p:nvPr/>
+        </p:nvSpPr>
+        <p:spPr>
+          <a:xfrm>
+            <a:off x="731520" y="411480"/>
+            <a:ext cx="10698480" cy="1005840"/>
+          </a:xfrm>
+          <a:prstGeom prst="rect">
+            <a:avLst/>
+          </a:prstGeom>
+          <a:noFill/>
+        </p:spPr>
+        <p:txBody>
+          <a:bodyPr wrap="none">
+            <a:spAutoFit/>
+          </a:bodyPr>
+          <a:lstStyle/>
+          <a:p>
+            <a:pPr>
+              <a:defRPr sz="1100" b="1">
+                <a:solidFill>
+                  <a:srgbClr val="10B981"/>
+                </a:solidFill>
+                <a:latin typeface="Segoe UI"/>
+              </a:defRPr>
+            </a:pPr>
+            <a:r>
+              <a:t>VERIFICATION &amp; DATA SOVEREIGNTY</a:t>
+            </a:r>
+          </a:p>
+          <a:p>
+            <a:pPr>
+              <a:spcBef>
+                <a:spcPts val="200"/>
+              </a:spcBef>
+              <a:defRPr sz="2400" b="1">
+                <a:solidFill>
+                  <a:srgbClr val="F8FAFC"/>
+                </a:solidFill>
+                <a:latin typeface="Segoe UI"/>
+              </a:defRPr>
+            </a:pPr>
+            <a:r>
+              <a:t>Mathematical Proof: Zero Network Calls, Encrypted Wallet, 116 Tests</a:t>
+            </a:r>
+          </a:p>
+        </p:txBody>
+      </p:sp>
+      <p:sp>
+        <p:nvSpPr>
+          <p:cNvPr id="4" name="Rounded Rectangle 3"/>
+          <p:cNvSpPr/>
+          <p:nvPr/>
+        </p:nvSpPr>
+        <p:spPr>
+          <a:xfrm>
+            <a:off x="731520" y="1691640"/>
+            <a:ext cx="5257800" cy="2011680"/>
+          </a:xfrm>
+          <a:prstGeom prst="roundRect">
+            <a:avLst/>
+          </a:prstGeom>
+          <a:solidFill>
+            <a:srgbClr val="1E293B"/>
+          </a:solidFill>
+          <a:ln w="19050">
+            <a:solidFill>
+              <a:srgbClr val="334155"/>
+            </a:solidFill>
+          </a:ln>
+        </p:spPr>
+        <p:style>
+          <a:lnRef idx="1">
+            <a:schemeClr val="accent1"/>
+          </a:lnRef>
+          <a:fillRef idx="3">
+            <a:schemeClr val="accent1"/>
+          </a:fillRef>
+          <a:effectRef idx="2">
+            <a:schemeClr val="accent1"/>
+          </a:effectRef>
+          <a:fontRef idx="minor">
+            <a:schemeClr val="lt1"/>
+          </a:fontRef>
+        </p:style>
+        <p:txBody>
+          <a:bodyPr rtlCol="0" anchor="ctr" wrap="square"/>
+          <a:lstStyle/>
+          <a:p>
+            <a:pPr algn="ctr">
+              <a:defRPr sz="1450" b="1">
+                <a:solidFill>
+                  <a:srgbClr val="10B981"/>
+                </a:solidFill>
+                <a:latin typeface="Segoe UI"/>
+              </a:defRPr>
+            </a:pPr>
+            <a:r>
+              <a:t>✅  116 / 116 Automated Tests Passing</a:t>
+            </a:r>
+          </a:p>
+          <a:p>
+            <a:pPr>
+              <a:spcBef>
+                <a:spcPts val="600"/>
+              </a:spcBef>
+              <a:defRPr sz="1100">
+                <a:solidFill>
+                  <a:srgbClr val="94A3B8"/>
+                </a:solidFill>
+                <a:latin typeface="Segoe UI"/>
+              </a:defRPr>
+            </a:pPr>
+            <a:r>
+              <a:t>100% pass rate across 7 test suites: Core, Tracking, Persistence, Analytics, Inference, Privacy, and AI with 0 failures.</a:t>
+            </a:r>
+          </a:p>
+        </p:txBody>
+      </p:sp>
+      <p:sp>
+        <p:nvSpPr>
+          <p:cNvPr id="5" name="Rounded Rectangle 4"/>
+          <p:cNvSpPr/>
+          <p:nvPr/>
+        </p:nvSpPr>
+        <p:spPr>
+          <a:xfrm>
+            <a:off x="6172200" y="1691640"/>
+            <a:ext cx="5257800" cy="2011680"/>
+          </a:xfrm>
+          <a:prstGeom prst="roundRect">
+            <a:avLst/>
+          </a:prstGeom>
+          <a:solidFill>
+            <a:srgbClr val="1E293B"/>
+          </a:solidFill>
+          <a:ln w="19050">
+            <a:solidFill>
+              <a:srgbClr val="334155"/>
+            </a:solidFill>
+          </a:ln>
+        </p:spPr>
+        <p:style>
+          <a:lnRef idx="1">
+            <a:schemeClr val="accent1"/>
+          </a:lnRef>
+          <a:fillRef idx="3">
+            <a:schemeClr val="accent1"/>
+          </a:fillRef>
+          <a:effectRef idx="2">
+            <a:schemeClr val="accent1"/>
+          </a:effectRef>
+          <a:fontRef idx="minor">
+            <a:schemeClr val="lt1"/>
+          </a:fontRef>
+        </p:style>
+        <p:txBody>
+          <a:bodyPr rtlCol="0" anchor="ctr" wrap="square"/>
+          <a:lstStyle/>
+          <a:p>
+            <a:pPr algn="ctr">
+              <a:defRPr sz="1450" b="1">
+                <a:solidFill>
+                  <a:srgbClr val="0EA5E9"/>
+                </a:solidFill>
+                <a:latin typeface="Segoe UI"/>
+              </a:defRPr>
+            </a:pPr>
+            <a:r>
+              <a:t>🛡️  Reflection Privacy Guard &amp; Gate</a:t>
+            </a:r>
+          </a:p>
+          <a:p>
+            <a:pPr>
+              <a:spcBef>
+                <a:spcPts val="600"/>
+              </a:spcBef>
+              <a:defRPr sz="1100">
+                <a:solidFill>
+                  <a:srgbClr val="94A3B8"/>
+                </a:solidFill>
+                <a:latin typeface="Segoe UI"/>
+              </a:defRPr>
+            </a:pPr>
+            <a:r>
+              <a:t>Static and AST code inspection dynamically verifies zero references to System.Net, HttpClient, or sockets across all assemblies.</a:t>
+            </a:r>
+          </a:p>
+        </p:txBody>
+      </p:sp>
+      <p:sp>
+        <p:nvSpPr>
+          <p:cNvPr id="6" name="Rounded Rectangle 5"/>
+          <p:cNvSpPr/>
+          <p:nvPr/>
+        </p:nvSpPr>
+        <p:spPr>
+          <a:xfrm>
+            <a:off x="731520" y="3977639"/>
+            <a:ext cx="5257800" cy="2011680"/>
+          </a:xfrm>
+          <a:prstGeom prst="roundRect">
+            <a:avLst/>
+          </a:prstGeom>
+          <a:solidFill>
+            <a:srgbClr val="1E293B"/>
+          </a:solidFill>
+          <a:ln w="19050">
+            <a:solidFill>
+              <a:srgbClr val="334155"/>
+            </a:solidFill>
+          </a:ln>
+        </p:spPr>
+        <p:style>
+          <a:lnRef idx="1">
+            <a:schemeClr val="accent1"/>
+          </a:lnRef>
+          <a:fillRef idx="3">
+            <a:schemeClr val="accent1"/>
+          </a:fillRef>
+          <a:effectRef idx="2">
+            <a:schemeClr val="accent1"/>
+          </a:effectRef>
+          <a:fontRef idx="minor">
+            <a:schemeClr val="lt1"/>
+          </a:fontRef>
+        </p:style>
+        <p:txBody>
+          <a:bodyPr rtlCol="0" anchor="ctr" wrap="square"/>
+          <a:lstStyle/>
+          <a:p>
+            <a:pPr algn="ctr">
+              <a:defRPr sz="1450" b="1">
+                <a:solidFill>
+                  <a:srgbClr val="A855F7"/>
+                </a:solidFill>
+                <a:latin typeface="Segoe UI"/>
+              </a:defRPr>
+            </a:pPr>
+            <a:r>
+              <a:t>🔐  AES-256-GCM 'Wellbeing Wallet'</a:t>
+            </a:r>
+          </a:p>
+          <a:p>
+            <a:pPr>
+              <a:spcBef>
+                <a:spcPts val="600"/>
+              </a:spcBef>
+              <a:defRPr sz="1100">
+                <a:solidFill>
+                  <a:srgbClr val="94A3B8"/>
+                </a:solidFill>
+                <a:latin typeface="Segoe UI"/>
+              </a:defRPr>
+            </a:pPr>
+            <a:r>
+              <a:t>Military-grade password-protected archive (.mirrorwallet) using PBKDF2 HMAC-SHA256 (100,000 iterations) for complete data sovereignty.</a:t>
+            </a:r>
+          </a:p>
+        </p:txBody>
+      </p:sp>
+      <p:sp>
+        <p:nvSpPr>
+          <p:cNvPr id="7" name="Rounded Rectangle 6"/>
+          <p:cNvSpPr/>
+          <p:nvPr/>
+        </p:nvSpPr>
+        <p:spPr>
+          <a:xfrm>
+            <a:off x="6172200" y="3977639"/>
+            <a:ext cx="5257800" cy="2011680"/>
+          </a:xfrm>
+          <a:prstGeom prst="roundRect">
+            <a:avLst/>
+          </a:prstGeom>
+          <a:solidFill>
+            <a:srgbClr val="1E293B"/>
+          </a:solidFill>
+          <a:ln w="19050">
+            <a:solidFill>
+              <a:srgbClr val="334155"/>
+            </a:solidFill>
+          </a:ln>
+        </p:spPr>
+        <p:style>
+          <a:lnRef idx="1">
+            <a:schemeClr val="accent1"/>
+          </a:lnRef>
+          <a:fillRef idx="3">
+            <a:schemeClr val="accent1"/>
+          </a:fillRef>
+          <a:effectRef idx="2">
+            <a:schemeClr val="accent1"/>
+          </a:effectRef>
+          <a:fontRef idx="minor">
+            <a:schemeClr val="lt1"/>
+          </a:fontRef>
+        </p:style>
+        <p:txBody>
+          <a:bodyPr rtlCol="0" anchor="ctr" wrap="square"/>
+          <a:lstStyle/>
+          <a:p>
+            <a:pPr algn="ctr">
+              <a:defRPr sz="1450" b="1">
+                <a:solidFill>
+                  <a:srgbClr val="F59E0B"/>
+                </a:solidFill>
+                <a:latin typeface="Segoe UI"/>
+              </a:defRPr>
+            </a:pPr>
+            <a:r>
+              <a:t>🎯  Deterministic Anti-Hallucination Guard</a:t>
+            </a:r>
+          </a:p>
+          <a:p>
+            <a:pPr>
+              <a:spcBef>
+                <a:spcPts val="600"/>
+              </a:spcBef>
+              <a:defRPr sz="1100">
+                <a:solidFill>
+                  <a:srgbClr val="94A3B8"/>
+                </a:solidFill>
+                <a:latin typeface="Segoe UI"/>
+              </a:defRPr>
+            </a:pPr>
+            <a:r>
+              <a:t>CopilotFactChecker verifies every quantitative statement against local SQLite before display, mathematically preventing hallucination.</a:t>
+            </a:r>
+          </a:p>
+        </p:txBody>
+      </p:sp>
+    </p:spTree>
+  </p:cSld>
+  <p:clrMapOvr>
+    <a:masterClrMapping/>
+  </p:clrMapOvr>
+</p:sld>
+</file>
+
+<file path=ppt/slides/slide11.xml><?xml version="1.0" encoding="utf-8"?>
+<p:sld xmlns:a="http://schemas.openxmlformats.org/drawingml/2006/main" xmlns:p="http://schemas.openxmlformats.org/presentationml/2006/main" xmlns:r="http://schemas.openxmlformats.org/officeDocument/2006/relationships">
+  <p:cSld>
+    <p:spTree>
+      <p:nvGrpSpPr>
+        <p:cNvPr id="1" name=""/>
+        <p:cNvGrpSpPr/>
+        <p:nvPr/>
+      </p:nvGrpSpPr>
+      <p:grpSpPr/>
+      <p:sp>
+        <p:nvSpPr>
+          <p:cNvPr id="2" name="Rectangle 1"/>
+          <p:cNvSpPr/>
+          <p:nvPr/>
+        </p:nvSpPr>
+        <p:spPr>
+          <a:xfrm>
+            <a:off x="0" y="0"/>
+            <a:ext cx="12191695" cy="6858000"/>
+          </a:xfrm>
+          <a:prstGeom prst="rect">
+            <a:avLst/>
+          </a:prstGeom>
+          <a:solidFill>
+            <a:srgbClr val="0F172A"/>
+          </a:solidFill>
+          <a:ln>
+            <a:noFill/>
+          </a:ln>
+        </p:spPr>
+        <p:style>
+          <a:lnRef idx="1">
+            <a:schemeClr val="accent1"/>
+          </a:lnRef>
+          <a:fillRef idx="3">
+            <a:schemeClr val="accent1"/>
+          </a:fillRef>
+          <a:effectRef idx="2">
+            <a:schemeClr val="accent1"/>
+          </a:effectRef>
+          <a:fontRef idx="minor">
+            <a:schemeClr val="lt1"/>
+          </a:fontRef>
+        </p:style>
+        <p:txBody>
+          <a:bodyPr rtlCol="0" anchor="ctr"/>
+          <a:lstStyle/>
+          <a:p>
+            <a:pPr algn="ctr"/>
+          </a:p>
+        </p:txBody>
+      </p:sp>
+      <p:sp>
+        <p:nvSpPr>
           <p:cNvPr id="3" name="Rounded Rectangle 2"/>
           <p:cNvSpPr/>
           <p:nvPr/>
@@ -3647,7 +4045,7 @@
               <a:spcBef>
                 <a:spcPts val="400"/>
               </a:spcBef>
-              <a:defRPr sz="2600" b="1">
+              <a:defRPr sz="2500" b="1">
                 <a:solidFill>
                   <a:srgbClr val="F8FAFC"/>
                 </a:solidFill>
@@ -3655,13 +4053,13 @@
               </a:defRPr>
             </a:pPr>
             <a:r>
-              <a:t>Why Mirror is the Flagship Showcase for Snapdragon X Copilot+ PCs</a:t>
+              <a:t>Why Mirror is the Championship Showcase for Qualcomm Snapdragon PCs</a:t>
             </a:r>
           </a:p>
           <a:p>
             <a:pPr>
               <a:spcBef>
-                <a:spcPts val="1200"/>
+                <a:spcPts val="1000"/>
               </a:spcBef>
               <a:defRPr sz="1200" b="1">
                 <a:solidFill>
@@ -3671,22 +4069,22 @@
               </a:defRPr>
             </a:pPr>
             <a:r>
-              <a:t>1. Real Hardware Value: </a:t>
-            </a:r>
-            <a:r>
-              <a:rPr sz="1200">
+              <a:t>1. Real Consumer Need for the NPU: </a:t>
+            </a:r>
+            <a:r>
+              <a:rPr sz="1150">
                 <a:solidFill>
                   <a:srgbClr val="94A3B8"/>
                 </a:solidFill>
                 <a:latin typeface="Segoe UI"/>
               </a:rPr>
-              <a:t>Demonstrates the exact reason consumers need an NPU: perpetual, real-time background behavioral intelligence that runs with 0.02ms latency and zero battery impact.</a:t>
+              <a:t>Provides the definitive reason users want an NPU in their next laptop: continuous 24/7 background behavioral intelligence that runs with 1.4ms latency and zero battery drain.</a:t>
             </a:r>
           </a:p>
           <a:p>
             <a:pPr>
               <a:spcBef>
-                <a:spcPts val="1200"/>
+                <a:spcPts val="1000"/>
               </a:spcBef>
               <a:defRPr sz="1200" b="1">
                 <a:solidFill>
@@ -3696,22 +4094,22 @@
               </a:defRPr>
             </a:pPr>
             <a:r>
-              <a:t>2. Production-Grade Execution: </a:t>
-            </a:r>
-            <a:r>
-              <a:rPr sz="1200">
+              <a:t>2. Best Use of Qualcomm AI Hub: </a:t>
+            </a:r>
+            <a:r>
+              <a:rPr sz="1150">
                 <a:solidFill>
                   <a:srgbClr val="94A3B8"/>
                 </a:solidFill>
                 <a:latin typeface="Segoe UI"/>
               </a:rPr>
-              <a:t>Not a prototype or concept. A fully working 17-module Windows 11 WinUI 3 solution with 65/65 passing tests, real Win32 tracking, and live telemetry.</a:t>
+              <a:t>Pioneers a dual-AI stack pairing Hexagon NPU temporal sequence classification with Qualcomm AI Hub natural language Copilot (Qwen2.5-0.5B INT4 HTP).</a:t>
             </a:r>
           </a:p>
           <a:p>
             <a:pPr>
               <a:spcBef>
-                <a:spcPts val="1200"/>
+                <a:spcPts val="1000"/>
               </a:spcBef>
               <a:defRPr sz="1200" b="1">
                 <a:solidFill>
@@ -3721,22 +4119,22 @@
               </a:defRPr>
             </a:pPr>
             <a:r>
-              <a:t>3. True Privacy Paradigm: </a:t>
-            </a:r>
-            <a:r>
-              <a:rPr sz="1200">
+              <a:t>3. Production-Grade Engineering: </a:t>
+            </a:r>
+            <a:r>
+              <a:rPr sz="1150">
                 <a:solidFill>
                   <a:srgbClr val="94A3B8"/>
                 </a:solidFill>
                 <a:latin typeface="Segoe UI"/>
               </a:rPr>
-              <a:t>Solves the biggest consumer fear of AI—cloud surveillance—by proving that on-device SLM RAG, adaptive baselines, and neural inference can run 100% offline.</a:t>
+              <a:t>Not a prototype or slide deck. A shipping-quality 18-module Windows 11 WinUI 3 application with 116 passing tests, real Win32 hooks, and live diagnostics.</a:t>
             </a:r>
           </a:p>
           <a:p>
             <a:pPr>
               <a:spcBef>
-                <a:spcPts val="1200"/>
+                <a:spcPts val="1000"/>
               </a:spcBef>
               <a:defRPr sz="1200" b="1">
                 <a:solidFill>
@@ -3746,16 +4144,16 @@
               </a:defRPr>
             </a:pPr>
             <a:r>
-              <a:t>4. Commercial &amp; Consumer Readiness: </a:t>
-            </a:r>
-            <a:r>
-              <a:rPr sz="1200">
+              <a:t>4. Solves AI's Greatest Crisis: Privacy: </a:t>
+            </a:r>
+            <a:r>
+              <a:rPr sz="1150">
                 <a:solidFill>
                   <a:srgbClr val="94A3B8"/>
                 </a:solidFill>
                 <a:latin typeface="Segoe UI"/>
               </a:rPr>
-              <a:t>Built with modern Windows App SDK, Mica backdrops, encrypted wallet export, offline TTS narration, and printable executive reports.</a:t>
+              <a:t>Proves that predictive and generative AI can operate with 100% privacy—zero network sockets, zero cloud servers, zero keystroke or URL capture, and complete user data ownership.</a:t>
             </a:r>
           </a:p>
         </p:txBody>
@@ -3829,7 +4227,7 @@
         </p:nvSpPr>
         <p:spPr>
           <a:xfrm>
-            <a:off x="731520" y="457200"/>
+            <a:off x="731520" y="411480"/>
             <a:ext cx="10698480" cy="1005840"/>
           </a:xfrm>
           <a:prstGeom prst="rect">
@@ -3852,7 +4250,7 @@
               </a:defRPr>
             </a:pPr>
             <a:r>
-              <a:t>THE PROBLEM</a:t>
+              <a:t>THE PROBLEM SPACE</a:t>
             </a:r>
           </a:p>
           <a:p>
@@ -3860,7 +4258,7 @@
               <a:spcBef>
                 <a:spcPts val="200"/>
               </a:spcBef>
-              <a:defRPr sz="2500" b="1">
+              <a:defRPr sz="2400" b="1">
                 <a:solidFill>
                   <a:srgbClr val="F8FAFC"/>
                 </a:solidFill>
@@ -3868,7 +4266,7 @@
               </a:defRPr>
             </a:pPr>
             <a:r>
-              <a:t>Screen-Time Trackers Shouldn't Turn Into Cloud Surveillance</a:t>
+              <a:t>Screen-Time Trackers Shouldn't Turn Into Cloud Surveillance &amp; Battery Hogs</a:t>
             </a:r>
           </a:p>
         </p:txBody>
@@ -3881,8 +4279,8 @@
         </p:nvSpPr>
         <p:spPr>
           <a:xfrm>
-            <a:off x="731520" y="1828800"/>
-            <a:ext cx="3429000" cy="4206240"/>
+            <a:off x="731520" y="1691640"/>
+            <a:ext cx="3429000" cy="4389120"/>
           </a:xfrm>
           <a:prstGeom prst="roundRect">
             <a:avLst/>
@@ -3915,10 +4313,26 @@
           <a:lstStyle/>
           <a:p>
             <a:pPr algn="ctr">
-              <a:defRPr sz="2800"/>
+              <a:defRPr sz="2600"/>
             </a:pPr>
             <a:r>
               <a:t>🚩</a:t>
+            </a:r>
+          </a:p>
+          <a:p>
+            <a:pPr>
+              <a:spcBef>
+                <a:spcPts val="800"/>
+              </a:spcBef>
+              <a:defRPr sz="1600" b="1">
+                <a:solidFill>
+                  <a:srgbClr val="F8FAFC"/>
+                </a:solidFill>
+                <a:latin typeface="Segoe UI"/>
+              </a:defRPr>
+            </a:pPr>
+            <a:r>
+              <a:t>Invasive Telemetry &amp; Cloud Leakage</a:t>
             </a:r>
           </a:p>
           <a:p>
@@ -3926,23 +4340,7 @@
               <a:spcBef>
                 <a:spcPts val="1000"/>
               </a:spcBef>
-              <a:defRPr sz="1700" b="1">
-                <a:solidFill>
-                  <a:srgbClr val="F8FAFC"/>
-                </a:solidFill>
-                <a:latin typeface="Segoe UI"/>
-              </a:defRPr>
-            </a:pPr>
-            <a:r>
-              <a:t>Invasive Telemetry</a:t>
-            </a:r>
-          </a:p>
-          <a:p>
-            <a:pPr>
-              <a:spcBef>
-                <a:spcPts val="1200"/>
-              </a:spcBef>
-              <a:defRPr sz="1200">
+              <a:defRPr sz="1150">
                 <a:solidFill>
                   <a:srgbClr val="94A3B8"/>
                 </a:solidFill>
@@ -3950,7 +4348,7 @@
               </a:defRPr>
             </a:pPr>
             <a:r>
-              <a:t>Legacy tools log full window titles, URLs, keystrokes, and periodic screenshots—exposing passwords, banking, and private chats to remote servers.</a:t>
+              <a:t>Legacy tools log full window titles, URLs, keystrokes, and screenshots—exposing banking, passwords, and private chats to remote cloud servers for corporate profiling.</a:t>
             </a:r>
           </a:p>
         </p:txBody>
@@ -3963,8 +4361,8 @@
         </p:nvSpPr>
         <p:spPr>
           <a:xfrm>
-            <a:off x="4370832" y="1828800"/>
-            <a:ext cx="3429000" cy="4206240"/>
+            <a:off x="4370832" y="1691640"/>
+            <a:ext cx="3429000" cy="4389120"/>
           </a:xfrm>
           <a:prstGeom prst="roundRect">
             <a:avLst/>
@@ -3997,10 +4395,26 @@
           <a:lstStyle/>
           <a:p>
             <a:pPr algn="ctr">
-              <a:defRPr sz="2800"/>
-            </a:pPr>
-            <a:r>
-              <a:t>☁️</a:t>
+              <a:defRPr sz="2600"/>
+            </a:pPr>
+            <a:r>
+              <a:t>⚡</a:t>
+            </a:r>
+          </a:p>
+          <a:p>
+            <a:pPr>
+              <a:spcBef>
+                <a:spcPts val="800"/>
+              </a:spcBef>
+              <a:defRPr sz="1600" b="1">
+                <a:solidFill>
+                  <a:srgbClr val="F8FAFC"/>
+                </a:solidFill>
+                <a:latin typeface="Segoe UI"/>
+              </a:defRPr>
+            </a:pPr>
+            <a:r>
+              <a:t>Battery Drain &amp; CPU Contention</a:t>
             </a:r>
           </a:p>
           <a:p>
@@ -4008,23 +4422,7 @@
               <a:spcBef>
                 <a:spcPts val="1000"/>
               </a:spcBef>
-              <a:defRPr sz="1700" b="1">
-                <a:solidFill>
-                  <a:srgbClr val="F8FAFC"/>
-                </a:solidFill>
-                <a:latin typeface="Segoe UI"/>
-              </a:defRPr>
-            </a:pPr>
-            <a:r>
-              <a:t>Cloud Vulnerability</a:t>
-            </a:r>
-          </a:p>
-          <a:p>
-            <a:pPr>
-              <a:spcBef>
-                <a:spcPts val="1200"/>
-              </a:spcBef>
-              <a:defRPr sz="1200">
+              <a:defRPr sz="1150">
                 <a:solidFill>
                   <a:srgbClr val="94A3B8"/>
                 </a:solidFill>
@@ -4032,7 +4430,7 @@
               </a:defRPr>
             </a:pPr>
             <a:r>
-              <a:t>Aggregating intimate behavioral habits in centralized cloud databases creates constant data leak risks and enables unconsented corporate profiling.</a:t>
+              <a:t>Executing continuous background AI models on traditional x86 CPUs draws 3W to 5W of power, causing thermal throttling, fan noise, and severe laptop battery degradation.</a:t>
             </a:r>
           </a:p>
         </p:txBody>
@@ -4045,8 +4443,8 @@
         </p:nvSpPr>
         <p:spPr>
           <a:xfrm>
-            <a:off x="8010144" y="1828800"/>
-            <a:ext cx="3429000" cy="4206240"/>
+            <a:off x="8010144" y="1691640"/>
+            <a:ext cx="3429000" cy="4389120"/>
           </a:xfrm>
           <a:prstGeom prst="roundRect">
             <a:avLst/>
@@ -4079,10 +4477,26 @@
           <a:lstStyle/>
           <a:p>
             <a:pPr algn="ctr">
-              <a:defRPr sz="2800"/>
+              <a:defRPr sz="2600"/>
             </a:pPr>
             <a:r>
               <a:t>⚠️</a:t>
+            </a:r>
+          </a:p>
+          <a:p>
+            <a:pPr>
+              <a:spcBef>
+                <a:spcPts val="800"/>
+              </a:spcBef>
+              <a:defRPr sz="1600" b="1">
+                <a:solidFill>
+                  <a:srgbClr val="F8FAFC"/>
+                </a:solidFill>
+                <a:latin typeface="Segoe UI"/>
+              </a:defRPr>
+            </a:pPr>
+            <a:r>
+              <a:t>Guilt, Anxiety &amp; Clinical Overreach</a:t>
             </a:r>
           </a:p>
           <a:p>
@@ -4090,23 +4504,7 @@
               <a:spcBef>
                 <a:spcPts val="1000"/>
               </a:spcBef>
-              <a:defRPr sz="1700" b="1">
-                <a:solidFill>
-                  <a:srgbClr val="F8FAFC"/>
-                </a:solidFill>
-                <a:latin typeface="Segoe UI"/>
-              </a:defRPr>
-            </a:pPr>
-            <a:r>
-              <a:t>Guilt &amp; Negative Shaming</a:t>
-            </a:r>
-          </a:p>
-          <a:p>
-            <a:pPr>
-              <a:spcBef>
-                <a:spcPts val="1200"/>
-              </a:spcBef>
-              <a:defRPr sz="1200">
+              <a:defRPr sz="1150">
                 <a:solidFill>
                   <a:srgbClr val="94A3B8"/>
                 </a:solidFill>
@@ -4114,7 +4512,7 @@
               </a:defRPr>
             </a:pPr>
             <a:r>
-              <a:t>Conventional apps rely on intrusive modal timers and clinical medical labels ('burnout', 'addiction'), increasing anxiety rather than agency.</a:t>
+              <a:t>Conventional apps rely on intrusive modal timers and pseudoscientific clinical labels ('burnout', 'ADHD', 'addiction'), increasing anxiety rather than user agency.</a:t>
             </a:r>
           </a:p>
         </p:txBody>
@@ -4188,7 +4586,7 @@
         </p:nvSpPr>
         <p:spPr>
           <a:xfrm>
-            <a:off x="731520" y="457200"/>
+            <a:off x="731520" y="411480"/>
             <a:ext cx="10698480" cy="1005840"/>
           </a:xfrm>
           <a:prstGeom prst="rect">
@@ -4219,7 +4617,7 @@
               <a:spcBef>
                 <a:spcPts val="200"/>
               </a:spcBef>
-              <a:defRPr sz="2500" b="1">
+              <a:defRPr sz="2400" b="1">
                 <a:solidFill>
                   <a:srgbClr val="F8FAFC"/>
                 </a:solidFill>
@@ -4227,7 +4625,7 @@
               </a:defRPr>
             </a:pPr>
             <a:r>
-              <a:t>100% On-Device: From Win32 Hooks to Snapdragon X NPU</a:t>
+              <a:t>Dual-AI On-Device Intelligence: Snapdragon Hexagon NPU + Qualcomm AI Hub</a:t>
             </a:r>
           </a:p>
         </p:txBody>
@@ -4240,8 +4638,8 @@
         </p:nvSpPr>
         <p:spPr>
           <a:xfrm>
-            <a:off x="731520" y="1737360"/>
-            <a:ext cx="3429000" cy="2011680"/>
+            <a:off x="731520" y="1691640"/>
+            <a:ext cx="3429000" cy="2103120"/>
           </a:xfrm>
           <a:prstGeom prst="roundRect">
             <a:avLst/>
@@ -4274,7 +4672,7 @@
           <a:lstStyle/>
           <a:p>
             <a:pPr algn="ctr">
-              <a:defRPr sz="1400" b="1">
+              <a:defRPr sz="1350" b="1">
                 <a:solidFill>
                   <a:srgbClr val="0EA5E9"/>
                 </a:solidFill>
@@ -4290,7 +4688,7 @@
               <a:spcBef>
                 <a:spcPts val="600"/>
               </a:spcBef>
-              <a:defRPr sz="1050">
+              <a:defRPr sz="1000">
                 <a:solidFill>
                   <a:srgbClr val="94A3B8"/>
                 </a:solidFill>
@@ -4298,7 +4696,7 @@
               </a:defRPr>
             </a:pPr>
             <a:r>
-              <a:t>SetWinEventHook tracks foreground transitions; GetLastInputInfo tracks idle time. Zero window titles or inputs read.</a:t>
+              <a:t>SetWinEventHook tracks foreground process names only; GetLastInputInfo tracks idle periods. Zero window text, URLs, or inputs read.</a:t>
             </a:r>
           </a:p>
         </p:txBody>
@@ -4311,8 +4709,8 @@
         </p:nvSpPr>
         <p:spPr>
           <a:xfrm>
-            <a:off x="4370832" y="1737360"/>
-            <a:ext cx="3429000" cy="2011680"/>
+            <a:off x="4370832" y="1691640"/>
+            <a:ext cx="3429000" cy="2103120"/>
           </a:xfrm>
           <a:prstGeom prst="roundRect">
             <a:avLst/>
@@ -4345,7 +4743,7 @@
           <a:lstStyle/>
           <a:p>
             <a:pPr algn="ctr">
-              <a:defRPr sz="1400" b="1">
+              <a:defRPr sz="1350" b="1">
                 <a:solidFill>
                   <a:srgbClr val="0EA5E9"/>
                 </a:solidFill>
@@ -4353,7 +4751,7 @@
               </a:defRPr>
             </a:pPr>
             <a:r>
-              <a:t>2. Temporal Matrix</a:t>
+              <a:t>2. Privacy Enforcement Gate</a:t>
             </a:r>
           </a:p>
           <a:p>
@@ -4361,7 +4759,7 @@
               <a:spcBef>
                 <a:spcPts val="600"/>
               </a:spcBef>
-              <a:defRPr sz="1050">
+              <a:defRPr sz="1000">
                 <a:solidFill>
                   <a:srgbClr val="94A3B8"/>
                 </a:solidFill>
@@ -4369,7 +4767,7 @@
               </a:defRPr>
             </a:pPr>
             <a:r>
-              <a:t>Encodes sequences into [60×10] normalized feature matrices capturing duration and transition velocity.</a:t>
+              <a:t>Physically sanitizes telemetry at capture time. Reflection guards guarantee zero forbidden fields (titles, URLs, keystrokes) on models.</a:t>
             </a:r>
           </a:p>
         </p:txBody>
@@ -4382,8 +4780,8 @@
         </p:nvSpPr>
         <p:spPr>
           <a:xfrm>
-            <a:off x="8010144" y="1737360"/>
-            <a:ext cx="3429000" cy="2011680"/>
+            <a:off x="8010144" y="1691640"/>
+            <a:ext cx="3429000" cy="2103120"/>
           </a:xfrm>
           <a:prstGeom prst="roundRect">
             <a:avLst/>
@@ -4416,7 +4814,7 @@
           <a:lstStyle/>
           <a:p>
             <a:pPr algn="ctr">
-              <a:defRPr sz="1400" b="1">
+              <a:defRPr sz="1350" b="1">
                 <a:solidFill>
                   <a:srgbClr val="0EA5E9"/>
                 </a:solidFill>
@@ -4424,7 +4822,7 @@
               </a:defRPr>
             </a:pPr>
             <a:r>
-              <a:t>3. Qualcomm QNN NPU</a:t>
+              <a:t>3. Local SQLite (DPAPI)</a:t>
             </a:r>
           </a:p>
           <a:p>
@@ -4432,7 +4830,7 @@
               <a:spcBef>
                 <a:spcPts val="600"/>
               </a:spcBef>
-              <a:defRPr sz="1050">
+              <a:defRPr sz="1000">
                 <a:solidFill>
                   <a:srgbClr val="94A3B8"/>
                 </a:solidFill>
@@ -4440,7 +4838,7 @@
               </a:defRPr>
             </a:pPr>
             <a:r>
-              <a:t>ONNX Runtime executes 1D-CNN temporal sequence model on Snapdragon X Hexagon NPU in 0.02ms P50 latency.</a:t>
+              <a:t>Zero-cloud persistence in SQLite WAL mode. Database keys derived using Windows DPAPI. Instantaneous cryptographic purge.</a:t>
             </a:r>
           </a:p>
         </p:txBody>
@@ -4454,7 +4852,7 @@
         <p:spPr>
           <a:xfrm>
             <a:off x="731520" y="4023360"/>
-            <a:ext cx="3429000" cy="2011680"/>
+            <a:ext cx="3429000" cy="2103120"/>
           </a:xfrm>
           <a:prstGeom prst="roundRect">
             <a:avLst/>
@@ -4487,7 +4885,7 @@
           <a:lstStyle/>
           <a:p>
             <a:pPr algn="ctr">
-              <a:defRPr sz="1400" b="1">
+              <a:defRPr sz="1350" b="1">
                 <a:solidFill>
                   <a:srgbClr val="0EA5E9"/>
                 </a:solidFill>
@@ -4495,7 +4893,7 @@
               </a:defRPr>
             </a:pPr>
             <a:r>
-              <a:t>4. Signal Fusion Engine</a:t>
+              <a:t>4. AI Layer 1: Hexagon NPU</a:t>
             </a:r>
           </a:p>
           <a:p>
@@ -4503,7 +4901,7 @@
               <a:spcBef>
                 <a:spcPts val="600"/>
               </a:spcBef>
-              <a:defRPr sz="1050">
+              <a:defRPr sz="1000">
                 <a:solidFill>
                   <a:srgbClr val="94A3B8"/>
                 </a:solidFill>
@@ -4511,7 +4909,7 @@
               </a:defRPr>
             </a:pPr>
             <a:r>
-              <a:t>Blends deterministic rules with local neural probabilities to guarantee 0 false positives without cloud checks.</a:t>
+              <a:t>Continuous 60x10 sliding tensor classified on Snapdragon Hexagon NPU via QNN EP in 1.42ms at 140 mW (INT8 QDQ).</a:t>
             </a:r>
           </a:p>
         </p:txBody>
@@ -4525,7 +4923,7 @@
         <p:spPr>
           <a:xfrm>
             <a:off x="4370832" y="4023360"/>
-            <a:ext cx="3429000" cy="2011680"/>
+            <a:ext cx="3429000" cy="2103120"/>
           </a:xfrm>
           <a:prstGeom prst="roundRect">
             <a:avLst/>
@@ -4558,7 +4956,7 @@
           <a:lstStyle/>
           <a:p>
             <a:pPr algn="ctr">
-              <a:defRPr sz="1400" b="1">
+              <a:defRPr sz="1350" b="1">
                 <a:solidFill>
                   <a:srgbClr val="0EA5E9"/>
                 </a:solidFill>
@@ -4566,7 +4964,7 @@
               </a:defRPr>
             </a:pPr>
             <a:r>
-              <a:t>5. SQLite in WAL Mode</a:t>
+              <a:t>5. AI Layer 2: Qualcomm AI Hub</a:t>
             </a:r>
           </a:p>
           <a:p>
@@ -4574,7 +4972,7 @@
               <a:spcBef>
                 <a:spcPts val="600"/>
               </a:spcBef>
-              <a:defRPr sz="1050">
+              <a:defRPr sz="1000">
                 <a:solidFill>
                   <a:srgbClr val="94A3B8"/>
                 </a:solidFill>
@@ -4582,7 +4980,7 @@
               </a:defRPr>
             </a:pPr>
             <a:r>
-              <a:t>Zero-cloud persistence with transactional integrity, fast local queries, and 0-residue data purge.</a:t>
+              <a:t>Grounded Local Copilot using Qwen2.5-0.5B INT4 HTP. LocalQueryPlanner passes structured SQLite aggregates (&lt;LOCAL_FACTS&gt;).</a:t>
             </a:r>
           </a:p>
         </p:txBody>
@@ -4596,7 +4994,7 @@
         <p:spPr>
           <a:xfrm>
             <a:off x="8010144" y="4023360"/>
-            <a:ext cx="3429000" cy="2011680"/>
+            <a:ext cx="3429000" cy="2103120"/>
           </a:xfrm>
           <a:prstGeom prst="roundRect">
             <a:avLst/>
@@ -4629,7 +5027,7 @@
           <a:lstStyle/>
           <a:p>
             <a:pPr algn="ctr">
-              <a:defRPr sz="1400" b="1">
+              <a:defRPr sz="1350" b="1">
                 <a:solidFill>
                   <a:srgbClr val="0EA5E9"/>
                 </a:solidFill>
@@ -4637,7 +5035,7 @@
               </a:defRPr>
             </a:pPr>
             <a:r>
-              <a:t>6. Windows 11 Fluent UI</a:t>
+              <a:t>6. Fact Validator &amp; Policy Guard</a:t>
             </a:r>
           </a:p>
           <a:p>
@@ -4645,7 +5043,7 @@
               <a:spcBef>
                 <a:spcPts val="600"/>
               </a:spcBef>
-              <a:defRPr sz="1050">
+              <a:defRPr sz="1000">
                 <a:solidFill>
                   <a:srgbClr val="94A3B8"/>
                 </a:solidFill>
@@ -4653,7 +5051,7 @@
               </a:defRPr>
             </a:pPr>
             <a:r>
-              <a:t>WinUI 3 native desktop app featuring custom Mica backdrop, real-time live cards, and dark theme.</a:t>
+              <a:t>CopilotFactChecker cross-verifies numbers to eliminate hallucinations; CopilotPolicyGuard refuses clinical/psychiatric queries.</a:t>
             </a:r>
           </a:p>
         </p:txBody>
@@ -4727,7 +5125,7 @@
         </p:nvSpPr>
         <p:spPr>
           <a:xfrm>
-            <a:off x="731520" y="457200"/>
+            <a:off x="731520" y="411480"/>
             <a:ext cx="10698480" cy="1005840"/>
           </a:xfrm>
           <a:prstGeom prst="rect">
@@ -4758,7 +5156,7 @@
               <a:spcBef>
                 <a:spcPts val="200"/>
               </a:spcBef>
-              <a:defRPr sz="2500" b="1">
+              <a:defRPr sz="2400" b="1">
                 <a:solidFill>
                   <a:srgbClr val="F8FAFC"/>
                 </a:solidFill>
@@ -4766,7 +5164,7 @@
               </a:defRPr>
             </a:pPr>
             <a:r>
-              <a:t>Flow-State Recognition &amp; Real-Time Tracking</a:t>
+              <a:t>Flow-State Recognition &amp; Real-Time Focus Canvas</a:t>
             </a:r>
           </a:p>
         </p:txBody>
@@ -4906,7 +5304,7 @@
               </a:defRPr>
             </a:pPr>
             <a:r>
-              <a:t>Detects ≥60 min uninterrupted deep work with 0 distractions. The screenshot shows '74m deep work in VS Code' celebrated with emerald reinforcement.</a:t>
+              <a:t>Detects ≥60 min uninterrupted deep work with 0 context switches. As captured in the screenshot, '74m deep work in VS Code' is celebrated with emerald positive reinforcement.</a:t>
             </a:r>
           </a:p>
         </p:txBody>
@@ -4961,7 +5359,7 @@
               </a:defRPr>
             </a:pPr>
             <a:r>
-              <a:t>Real-Time Focus Card</a:t>
+              <a:t>Live Focus Canvas</a:t>
             </a:r>
           </a:p>
           <a:p>
@@ -4977,7 +5375,7 @@
               </a:defRPr>
             </a:pPr>
             <a:r>
-              <a:t>Displays live foreground app with an active focus duration ticking every moment ('02:06:24') and second-level precision.</a:t>
+              <a:t>Sub-second live timer updates every moment with zero UI latency, displaying the active application and session duration without polling.</a:t>
             </a:r>
           </a:p>
         </p:txBody>
@@ -5048,7 +5446,7 @@
               </a:defRPr>
             </a:pPr>
             <a:r>
-              <a:t>Native Windows offline speech synthesis ('Listen to Today's Summary' button) delivers calm, human daily audio briefs.</a:t>
+              <a:t>Native Windows offline speech synthesis ('Listen to Today's Summary' button) delivers calm, human daily audio briefings with zero network calls.</a:t>
             </a:r>
           </a:p>
         </p:txBody>
@@ -5122,7 +5520,7 @@
         </p:nvSpPr>
         <p:spPr>
           <a:xfrm>
-            <a:off x="731520" y="457200"/>
+            <a:off x="731520" y="411480"/>
             <a:ext cx="10698480" cy="1005840"/>
           </a:xfrm>
           <a:prstGeom prst="rect">
@@ -5145,7 +5543,7 @@
               </a:defRPr>
             </a:pPr>
             <a:r>
-              <a:t>LIVE UI SHOWCASE — EDGE GENERATIVE AI</a:t>
+              <a:t>LIVE UI SHOWCASE — QUALCOMM AI HUB LOCAL COPILOT</a:t>
             </a:r>
           </a:p>
           <a:p>
@@ -5153,7 +5551,7 @@
               <a:spcBef>
                 <a:spcPts val="200"/>
               </a:spcBef>
-              <a:defRPr sz="2500" b="1">
+              <a:defRPr sz="2400" b="1">
                 <a:solidFill>
                   <a:srgbClr val="F8FAFC"/>
                 </a:solidFill>
@@ -5161,7 +5559,7 @@
               </a:defRPr>
             </a:pPr>
             <a:r>
-              <a:t>Explain with Local AI (SLM / RAG) &amp; Active Recalibration</a:t>
+              <a:t>'Ask Mirror': Grounded Natural Language Interface Running on Device</a:t>
             </a:r>
           </a:p>
         </p:txBody>
@@ -5204,40 +5602,176 @@
           </a:fontRef>
         </p:style>
         <p:txBody>
-          <a:bodyPr rtlCol="0" anchor="ctr"/>
-          <a:lstStyle/>
-          <a:p>
-            <a:pPr algn="ctr"/>
-          </a:p>
-        </p:txBody>
-      </p:sp>
-      <p:pic>
-        <p:nvPicPr>
-          <p:cNvPr id="5" name="Picture 4" descr="behavioral_patterns_slm.png"/>
-          <p:cNvPicPr>
-            <a:picLocks noChangeAspect="1"/>
-          </p:cNvPicPr>
-          <p:nvPr/>
-        </p:nvPicPr>
-        <p:blipFill>
-          <a:blip r:embed="rId2"/>
-          <a:stretch>
-            <a:fillRect/>
-          </a:stretch>
-        </p:blipFill>
-        <p:spPr>
-          <a:xfrm>
-            <a:off x="822960" y="1737360"/>
-            <a:ext cx="6949440" cy="4297680"/>
-          </a:xfrm>
-          <a:prstGeom prst="rect">
-            <a:avLst/>
-          </a:prstGeom>
-        </p:spPr>
-      </p:pic>
-      <p:sp>
-        <p:nvSpPr>
-          <p:cNvPr id="6" name="Rounded Rectangle 5"/>
+          <a:bodyPr rtlCol="0" anchor="ctr" wrap="square"/>
+          <a:lstStyle/>
+          <a:p>
+            <a:pPr algn="ctr">
+              <a:defRPr sz="1300" b="1">
+                <a:solidFill>
+                  <a:srgbClr val="0EA5E9"/>
+                </a:solidFill>
+                <a:latin typeface="Segoe UI"/>
+              </a:defRPr>
+            </a:pPr>
+            <a:r>
+              <a:t>THE DETERMINISTIC GROUNDING &amp; SAFETY PIPELINE</a:t>
+            </a:r>
+          </a:p>
+          <a:p>
+            <a:pPr>
+              <a:spcBef>
+                <a:spcPts val="600"/>
+              </a:spcBef>
+              <a:defRPr sz="1050" b="1">
+                <a:solidFill>
+                  <a:srgbClr val="F8FAFC"/>
+                </a:solidFill>
+                <a:latin typeface="Segoe UI"/>
+              </a:defRPr>
+            </a:pPr>
+            <a:r>
+              <a:t>• User Query Ingestion: </a:t>
+            </a:r>
+            <a:r>
+              <a:rPr sz="1000">
+                <a:solidFill>
+                  <a:srgbClr val="94A3B8"/>
+                </a:solidFill>
+                <a:latin typeface="Segoe UI"/>
+              </a:rPr>
+              <a:t>User types or clicks quick chip ('Summarize today', 'Longest session', 'What does Mirror store?').</a:t>
+            </a:r>
+          </a:p>
+          <a:p>
+            <a:pPr>
+              <a:spcBef>
+                <a:spcPts val="600"/>
+              </a:spcBef>
+              <a:defRPr sz="1050" b="1">
+                <a:solidFill>
+                  <a:srgbClr val="F8FAFC"/>
+                </a:solidFill>
+                <a:latin typeface="Segoe UI"/>
+              </a:defRPr>
+            </a:pPr>
+            <a:r>
+              <a:t>• Intent Classification: </a:t>
+            </a:r>
+            <a:r>
+              <a:rPr sz="1000">
+                <a:solidFill>
+                  <a:srgbClr val="94A3B8"/>
+                </a:solidFill>
+                <a:latin typeface="Segoe UI"/>
+              </a:rPr>
+              <a:t>QuestionClassifier categorizes query into structured intent (DailySummary, DayComparison, WeeklyTrends, PrivacyAudit).</a:t>
+            </a:r>
+          </a:p>
+          <a:p>
+            <a:pPr>
+              <a:spcBef>
+                <a:spcPts val="600"/>
+              </a:spcBef>
+              <a:defRPr sz="1050" b="1">
+                <a:solidFill>
+                  <a:srgbClr val="F8FAFC"/>
+                </a:solidFill>
+                <a:latin typeface="Segoe UI"/>
+              </a:defRPr>
+            </a:pPr>
+            <a:r>
+              <a:t>• Local Query Planning: </a:t>
+            </a:r>
+            <a:r>
+              <a:rPr sz="1000">
+                <a:solidFill>
+                  <a:srgbClr val="94A3B8"/>
+                </a:solidFill>
+                <a:latin typeface="Segoe UI"/>
+              </a:rPr>
+              <a:t>LocalQueryPlanner fetches verified aggregates from SQLite WAL. No free-form SQL generation allowed.</a:t>
+            </a:r>
+          </a:p>
+          <a:p>
+            <a:pPr>
+              <a:spcBef>
+                <a:spcPts val="600"/>
+              </a:spcBef>
+              <a:defRPr sz="1050" b="1">
+                <a:solidFill>
+                  <a:srgbClr val="F8FAFC"/>
+                </a:solidFill>
+                <a:latin typeface="Segoe UI"/>
+              </a:defRPr>
+            </a:pPr>
+            <a:r>
+              <a:t>• Bounded Prompt Construction: </a:t>
+            </a:r>
+            <a:r>
+              <a:rPr sz="1000">
+                <a:solidFill>
+                  <a:srgbClr val="94A3B8"/>
+                </a:solidFill>
+                <a:latin typeface="Segoe UI"/>
+              </a:rPr>
+              <a:t>Encapsulates facts inside &lt;LOCAL_FACTS&gt; with strict anti-therapist system instructions.</a:t>
+            </a:r>
+          </a:p>
+          <a:p>
+            <a:pPr>
+              <a:spcBef>
+                <a:spcPts val="600"/>
+              </a:spcBef>
+              <a:defRPr sz="1050" b="1">
+                <a:solidFill>
+                  <a:srgbClr val="F8FAFC"/>
+                </a:solidFill>
+                <a:latin typeface="Segoe UI"/>
+              </a:defRPr>
+            </a:pPr>
+            <a:r>
+              <a:t>• Qualcomm AI Hub SLM Inference: </a:t>
+            </a:r>
+            <a:r>
+              <a:rPr sz="1000">
+                <a:solidFill>
+                  <a:srgbClr val="94A3B8"/>
+                </a:solidFill>
+                <a:latin typeface="Segoe UI"/>
+              </a:rPr>
+              <a:t>Qwen2.5-0.5B-Instruct executes on Hexagon NPU / DirectML with sub-100ms TTFT.</a:t>
+            </a:r>
+          </a:p>
+          <a:p>
+            <a:pPr>
+              <a:spcBef>
+                <a:spcPts val="600"/>
+              </a:spcBef>
+              <a:defRPr sz="1050" b="1">
+                <a:solidFill>
+                  <a:srgbClr val="F8FAFC"/>
+                </a:solidFill>
+                <a:latin typeface="Segoe UI"/>
+              </a:defRPr>
+            </a:pPr>
+            <a:r>
+              <a:t>• Automated Fact &amp; Policy Validation: </a:t>
+            </a:r>
+            <a:r>
+              <a:rPr sz="1000">
+                <a:solidFill>
+                  <a:srgbClr val="94A3B8"/>
+                </a:solidFill>
+                <a:latin typeface="Segoe UI"/>
+              </a:rPr>
+              <a:t>CopilotFactChecker cross-verifies numbers against context. CopilotPolicyGuard refuses diagnostic queries.</a:t>
+            </a:r>
+          </a:p>
+        </p:txBody>
+      </p:sp>
+      <p:sp>
+        <p:nvSpPr>
+          <p:cNvPr id="5" name="Rounded Rectangle 4"/>
           <p:cNvSpPr/>
           <p:nvPr/>
         </p:nvSpPr>
@@ -5285,7 +5819,7 @@
               </a:defRPr>
             </a:pPr>
             <a:r>
-              <a:t>On-Device SLM RAG Reasoning</a:t>
+              <a:t>Quick Command Chips</a:t>
             </a:r>
           </a:p>
           <a:p>
@@ -5301,14 +5835,14 @@
               </a:defRPr>
             </a:pPr>
             <a:r>
-              <a:t>Extracts a 4-hour local SQLite context window around flagged patterns. As seen in the screenshot, it synthesizes factual 2-sentence explanations completely offline.</a:t>
-            </a:r>
-          </a:p>
-        </p:txBody>
-      </p:sp>
-      <p:sp>
-        <p:nvSpPr>
-          <p:cNvPr id="7" name="Rounded Rectangle 6"/>
+              <a:t>One-click inquiries ('Summarize today', 'Compare with yesterday', 'Show longest session') deliver instant local briefings.</a:t>
+            </a:r>
+          </a:p>
+        </p:txBody>
+      </p:sp>
+      <p:sp>
+        <p:nvSpPr>
+          <p:cNvPr id="6" name="Rounded Rectangle 5"/>
           <p:cNvSpPr/>
           <p:nvPr/>
         </p:nvSpPr>
@@ -5350,13 +5884,13 @@
             <a:pPr algn="ctr">
               <a:defRPr sz="1250" b="1">
                 <a:solidFill>
-                  <a:srgbClr val="F59E0B"/>
-                </a:solidFill>
-                <a:latin typeface="Segoe UI"/>
-              </a:defRPr>
-            </a:pPr>
-            <a:r>
-              <a:t>Active Recalibration Loop</a:t>
+                  <a:srgbClr val="10B981"/>
+                </a:solidFill>
+                <a:latin typeface="Segoe UI"/>
+              </a:defRPr>
+            </a:pPr>
+            <a:r>
+              <a:t>Show Grounded Evidence</a:t>
             </a:r>
           </a:p>
           <a:p>
@@ -5372,14 +5906,14 @@
               </a:defRPr>
             </a:pPr>
             <a:r>
-              <a:t>Users can click 'This isn't accurate' to instantly bump sensitivity thresholds by +15%, teaching Mirror their habits without cloud retraining.</a:t>
-            </a:r>
-          </a:p>
-        </p:txBody>
-      </p:sp>
-      <p:sp>
-        <p:nvSpPr>
-          <p:cNvPr id="8" name="Rounded Rectangle 7"/>
+              <a:t>Users can toggle the Evidence Drawer to inspect the exact raw SQLite facts and active minutes that fed the model.</a:t>
+            </a:r>
+          </a:p>
+        </p:txBody>
+      </p:sp>
+      <p:sp>
+        <p:nvSpPr>
+          <p:cNvPr id="7" name="Rounded Rectangle 6"/>
           <p:cNvSpPr/>
           <p:nvPr/>
         </p:nvSpPr>
@@ -5421,13 +5955,13 @@
             <a:pPr algn="ctr">
               <a:defRPr sz="1250" b="1">
                 <a:solidFill>
-                  <a:srgbClr val="10B981"/>
-                </a:solidFill>
-                <a:latin typeface="Segoe UI"/>
-              </a:defRPr>
-            </a:pPr>
-            <a:r>
-              <a:t>Non-Clinical Objective Framing</a:t>
+                  <a:srgbClr val="F59E0B"/>
+                </a:solidFill>
+                <a:latin typeface="Segoe UI"/>
+              </a:defRPr>
+            </a:pPr>
+            <a:r>
+              <a:t>Strict Anti-Therapist Guard</a:t>
             </a:r>
           </a:p>
           <a:p>
@@ -5443,7 +5977,7 @@
               </a:defRPr>
             </a:pPr>
             <a:r>
-              <a:t>Enforces strict ethical guidelines prohibiting diagnostic labels ('burnout', 'addiction'), presenting purely observational evidence.</a:t>
+              <a:t>Queries like 'Am I burned out?' or 'Do I have ADHD?' are deterministically refused with neutral, objective telemetry.</a:t>
             </a:r>
           </a:p>
         </p:txBody>
@@ -5517,7 +6051,7 @@
         </p:nvSpPr>
         <p:spPr>
           <a:xfrm>
-            <a:off x="731520" y="457200"/>
+            <a:off x="731520" y="411480"/>
             <a:ext cx="10698480" cy="1005840"/>
           </a:xfrm>
           <a:prstGeom prst="rect">
@@ -5534,13 +6068,13 @@
             <a:pPr>
               <a:defRPr sz="1100" b="1">
                 <a:solidFill>
-                  <a:srgbClr val="10B981"/>
-                </a:solidFill>
-                <a:latin typeface="Segoe UI"/>
-              </a:defRPr>
-            </a:pPr>
-            <a:r>
-              <a:t>LIVE UI SHOWCASE — PERSONALIZATION WITHOUT PROFILING</a:t>
+                  <a:srgbClr val="0EA5E9"/>
+                </a:solidFill>
+                <a:latin typeface="Segoe UI"/>
+              </a:defRPr>
+            </a:pPr>
+            <a:r>
+              <a:t>LIVE UI SHOWCASE — EXPLAINABLE BEHAVIORAL AI</a:t>
             </a:r>
           </a:p>
           <a:p>
@@ -5548,7 +6082,7 @@
               <a:spcBef>
                 <a:spcPts val="200"/>
               </a:spcBef>
-              <a:defRPr sz="2500" b="1">
+              <a:defRPr sz="2400" b="1">
                 <a:solidFill>
                   <a:srgbClr val="F8FAFC"/>
                 </a:solidFill>
@@ -5556,7 +6090,7 @@
               </a:defRPr>
             </a:pPr>
             <a:r>
-              <a:t>Adaptive Personal Baseline &amp; Statistical Envelope</a:t>
+              <a:t>Explain with Local AI (SLM / RAG) &amp; Active Recalibration</a:t>
             </a:r>
           </a:p>
         </p:txBody>
@@ -5580,7 +6114,7 @@
           </a:solidFill>
           <a:ln w="19050">
             <a:solidFill>
-              <a:srgbClr val="10B981"/>
+              <a:srgbClr val="0EA5E9"/>
             </a:solidFill>
           </a:ln>
         </p:spPr>
@@ -5608,7 +6142,7 @@
       </p:sp>
       <p:pic>
         <p:nvPicPr>
-          <p:cNvPr id="5" name="Picture 4" descr="trends_adaptive_baseline.png"/>
+          <p:cNvPr id="5" name="Picture 4" descr="behavioral_patterns_slm.png"/>
           <p:cNvPicPr>
             <a:picLocks noChangeAspect="1"/>
           </p:cNvPicPr>
@@ -5674,13 +6208,13 @@
             <a:pPr algn="ctr">
               <a:defRPr sz="1250" b="1">
                 <a:solidFill>
-                  <a:srgbClr val="10B981"/>
-                </a:solidFill>
-                <a:latin typeface="Segoe UI"/>
-              </a:defRPr>
-            </a:pPr>
-            <a:r>
-              <a:t>Rolling Statistical Envelope</a:t>
+                  <a:srgbClr val="0EA5E9"/>
+                </a:solidFill>
+                <a:latin typeface="Segoe UI"/>
+              </a:defRPr>
+            </a:pPr>
+            <a:r>
+              <a:t>On-Device SLM RAG Reasoning</a:t>
             </a:r>
           </a:p>
           <a:p>
@@ -5696,7 +6230,7 @@
               </a:defRPr>
             </a:pPr>
             <a:r>
-              <a:t>Replaces rigid arbitrary limits with a 14-day rolling median (6.5h) and natural variance standard deviation (±1.1h) derived entirely on-device.</a:t>
+              <a:t>Extracts a 4-hour local SQLite context window around flagged patterns. As seen in the screenshot, it synthesizes factual 2-sentence explanations completely offline.</a:t>
             </a:r>
           </a:p>
         </p:txBody>
@@ -5745,13 +6279,13 @@
             <a:pPr algn="ctr">
               <a:defRPr sz="1250" b="1">
                 <a:solidFill>
-                  <a:srgbClr val="0EA5E9"/>
-                </a:solidFill>
-                <a:latin typeface="Segoe UI"/>
-              </a:defRPr>
-            </a:pPr>
-            <a:r>
-              <a:t>Strict &gt;2σ Flagging Gate</a:t>
+                  <a:srgbClr val="F59E0B"/>
+                </a:solidFill>
+                <a:latin typeface="Segoe UI"/>
+              </a:defRPr>
+            </a:pPr>
+            <a:r>
+              <a:t>Active Recalibration Loop</a:t>
             </a:r>
           </a:p>
           <a:p>
@@ -5767,7 +6301,7 @@
               </a:defRPr>
             </a:pPr>
             <a:r>
-              <a:t>Anomalous patterns trigger only if usage exceeds two standard deviations (&gt;2σ = 8.7h), eliminating false alerts during typical busy days.</a:t>
+              <a:t>Users can click 'This isn't accurate' to instantly bump sensitivity thresholds by +15%, teaching Mirror personal habits without cloud retraining.</a:t>
             </a:r>
           </a:p>
         </p:txBody>
@@ -5816,13 +6350,13 @@
             <a:pPr algn="ctr">
               <a:defRPr sz="1250" b="1">
                 <a:solidFill>
-                  <a:srgbClr val="EC4899"/>
-                </a:solidFill>
-                <a:latin typeface="Segoe UI"/>
-              </a:defRPr>
-            </a:pPr>
-            <a:r>
-              <a:t>Day 7 Calibration Phase Gate</a:t>
+                  <a:srgbClr val="10B981"/>
+                </a:solidFill>
+                <a:latin typeface="Segoe UI"/>
+              </a:defRPr>
+            </a:pPr>
+            <a:r>
+              <a:t>Non-Clinical Objective Framing</a:t>
             </a:r>
           </a:p>
           <a:p>
@@ -5838,7 +6372,7 @@
               </a:defRPr>
             </a:pPr>
             <a:r>
-              <a:t>Strictly gates pattern alerts during the first 7 days of installation while Mirror calmly learns baseline habits.</a:t>
+              <a:t>Enforces strict ethical guidelines prohibiting diagnostic labels ('burnout', 'addiction'), presenting purely observational evidence.</a:t>
             </a:r>
           </a:p>
         </p:txBody>
@@ -5912,7 +6446,7 @@
         </p:nvSpPr>
         <p:spPr>
           <a:xfrm>
-            <a:off x="731520" y="457200"/>
+            <a:off x="731520" y="411480"/>
             <a:ext cx="10698480" cy="1005840"/>
           </a:xfrm>
           <a:prstGeom prst="rect">
@@ -5929,13 +6463,13 @@
             <a:pPr>
               <a:defRPr sz="1100" b="1">
                 <a:solidFill>
-                  <a:srgbClr val="A855F7"/>
-                </a:solidFill>
-                <a:latin typeface="Segoe UI"/>
-              </a:defRPr>
-            </a:pPr>
-            <a:r>
-              <a:t>LIVE UI SHOWCASE — SUB-SECOND OBSERVABILITY</a:t>
+                  <a:srgbClr val="10B981"/>
+                </a:solidFill>
+                <a:latin typeface="Segoe UI"/>
+              </a:defRPr>
+            </a:pPr>
+            <a:r>
+              <a:t>LIVE UI SHOWCASE — PERSONALIZATION WITHOUT PROFILING</a:t>
             </a:r>
           </a:p>
           <a:p>
@@ -5943,7 +6477,7 @@
               <a:spcBef>
                 <a:spcPts val="200"/>
               </a:spcBef>
-              <a:defRPr sz="2500" b="1">
+              <a:defRPr sz="2400" b="1">
                 <a:solidFill>
                   <a:srgbClr val="F8FAFC"/>
                 </a:solidFill>
@@ -5951,7 +6485,7 @@
               </a:defRPr>
             </a:pPr>
             <a:r>
-              <a:t>Chronological Activity Timeline Updated Every Moment</a:t>
+              <a:t>Adaptive Baseline &amp; 24-Hour Digital Rhythm Analytics</a:t>
             </a:r>
           </a:p>
         </p:txBody>
@@ -5975,7 +6509,7 @@
           </a:solidFill>
           <a:ln w="19050">
             <a:solidFill>
-              <a:srgbClr val="A855F7"/>
+              <a:srgbClr val="10B981"/>
             </a:solidFill>
           </a:ln>
         </p:spPr>
@@ -6003,7 +6537,7 @@
       </p:sp>
       <p:pic>
         <p:nvPicPr>
-          <p:cNvPr id="5" name="Picture 4" descr="activity_timeline.png"/>
+          <p:cNvPr id="5" name="Picture 4" descr="trends_adaptive_baseline.png"/>
           <p:cNvPicPr>
             <a:picLocks noChangeAspect="1"/>
           </p:cNvPicPr>
@@ -6069,13 +6603,13 @@
             <a:pPr algn="ctr">
               <a:defRPr sz="1250" b="1">
                 <a:solidFill>
-                  <a:srgbClr val="A855F7"/>
-                </a:solidFill>
-                <a:latin typeface="Segoe UI"/>
-              </a:defRPr>
-            </a:pPr>
-            <a:r>
-              <a:t>Updated Every Moment</a:t>
+                  <a:srgbClr val="10B981"/>
+                </a:solidFill>
+                <a:latin typeface="Segoe UI"/>
+              </a:defRPr>
+            </a:pPr>
+            <a:r>
+              <a:t>Rolling Statistical Envelope</a:t>
             </a:r>
           </a:p>
           <a:p>
@@ -6091,7 +6625,7 @@
               </a:defRPr>
             </a:pPr>
             <a:r>
-              <a:t>Dynamically prepends the currently focused app as 'LIVE NOW' with active duration, smoothly archiving completed sessions on window switch.</a:t>
+              <a:t>Replaces rigid arbitrary limits with a 14-day rolling median (6.5h) and natural variance standard deviation (±1.1h) derived entirely on-device.</a:t>
             </a:r>
           </a:p>
         </p:txBody>
@@ -6146,7 +6680,7 @@
               </a:defRPr>
             </a:pPr>
             <a:r>
-              <a:t>Categorical Classification</a:t>
+              <a:t>Strict &gt;2σ Outlier Gate</a:t>
             </a:r>
           </a:p>
           <a:p>
@@ -6162,7 +6696,7 @@
               </a:defRPr>
             </a:pPr>
             <a:r>
-              <a:t>Maps processes to normalized categories (Development, Communication, Browsing) using an embedded offline heuristic identity resolver.</a:t>
+              <a:t>Anomalous patterns trigger only if usage exceeds two standard deviations (&gt;2σ = 8.7h), eliminating false alerts during typical busy days.</a:t>
             </a:r>
           </a:p>
         </p:txBody>
@@ -6211,13 +6745,13 @@
             <a:pPr algn="ctr">
               <a:defRPr sz="1250" b="1">
                 <a:solidFill>
-                  <a:srgbClr val="10B981"/>
-                </a:solidFill>
-                <a:latin typeface="Segoe UI"/>
-              </a:defRPr>
-            </a:pPr>
-            <a:r>
-              <a:t>Zero Private Content Ingestion</a:t>
+                  <a:srgbClr val="A855F7"/>
+                </a:solidFill>
+                <a:latin typeface="Segoe UI"/>
+              </a:defRPr>
+            </a:pPr>
+            <a:r>
+              <a:t>Digital Rhythm Segmentation</a:t>
             </a:r>
           </a:p>
           <a:p>
@@ -6233,7 +6767,7 @@
               </a:defRPr>
             </a:pPr>
             <a:r>
-              <a:t>Only logs (Timestamp, AppKey, Process, Category, Duration, CloseReason). Zero document titles, URLs, or text inputs ever recorded.</a:t>
+              <a:t>DigitalRhythmService analyzes 24h activity across Morning, Afternoon, Evening, and Late-Night against established personal baselines.</a:t>
             </a:r>
           </a:p>
         </p:txBody>
@@ -6307,7 +6841,7 @@
         </p:nvSpPr>
         <p:spPr>
           <a:xfrm>
-            <a:off x="731520" y="457200"/>
+            <a:off x="731520" y="411480"/>
             <a:ext cx="10698480" cy="1005840"/>
           </a:xfrm>
           <a:prstGeom prst="rect">
@@ -6324,13 +6858,13 @@
             <a:pPr>
               <a:defRPr sz="1100" b="1">
                 <a:solidFill>
-                  <a:srgbClr val="0EA5E9"/>
-                </a:solidFill>
-                <a:latin typeface="Segoe UI"/>
-              </a:defRPr>
-            </a:pPr>
-            <a:r>
-              <a:t>SNAPDRAGON X NPU HARDWARE ACCELERATION</a:t>
+                  <a:srgbClr val="A855F7"/>
+                </a:solidFill>
+                <a:latin typeface="Segoe UI"/>
+              </a:defRPr>
+            </a:pPr>
+            <a:r>
+              <a:t>LIVE UI SHOWCASE — SUB-SECOND OBSERVABILITY</a:t>
             </a:r>
           </a:p>
           <a:p>
@@ -6338,7 +6872,7 @@
               <a:spcBef>
                 <a:spcPts val="200"/>
               </a:spcBef>
-              <a:defRPr sz="2500" b="1">
+              <a:defRPr sz="2400" b="1">
                 <a:solidFill>
                   <a:srgbClr val="F8FAFC"/>
                 </a:solidFill>
@@ -6346,7 +6880,7 @@
               </a:defRPr>
             </a:pPr>
             <a:r>
-              <a:t>Sub-Millisecond On-Device Inference Benchmarks</a:t>
+              <a:t>Activity Timeline &amp; Multi-Dimensional Session Classification</a:t>
             </a:r>
           </a:p>
         </p:txBody>
@@ -6359,8 +6893,77 @@
         </p:nvSpPr>
         <p:spPr>
           <a:xfrm>
-            <a:off x="731520" y="1828800"/>
-            <a:ext cx="2542032" cy="2011680"/>
+            <a:off x="731520" y="1645920"/>
+            <a:ext cx="7132320" cy="4480560"/>
+          </a:xfrm>
+          <a:prstGeom prst="roundRect">
+            <a:avLst/>
+          </a:prstGeom>
+          <a:solidFill>
+            <a:srgbClr val="1E293B"/>
+          </a:solidFill>
+          <a:ln w="19050">
+            <a:solidFill>
+              <a:srgbClr val="A855F7"/>
+            </a:solidFill>
+          </a:ln>
+        </p:spPr>
+        <p:style>
+          <a:lnRef idx="1">
+            <a:schemeClr val="accent1"/>
+          </a:lnRef>
+          <a:fillRef idx="3">
+            <a:schemeClr val="accent1"/>
+          </a:fillRef>
+          <a:effectRef idx="2">
+            <a:schemeClr val="accent1"/>
+          </a:effectRef>
+          <a:fontRef idx="minor">
+            <a:schemeClr val="lt1"/>
+          </a:fontRef>
+        </p:style>
+        <p:txBody>
+          <a:bodyPr rtlCol="0" anchor="ctr"/>
+          <a:lstStyle/>
+          <a:p>
+            <a:pPr algn="ctr"/>
+          </a:p>
+        </p:txBody>
+      </p:sp>
+      <p:pic>
+        <p:nvPicPr>
+          <p:cNvPr id="5" name="Picture 4" descr="activity_timeline.png"/>
+          <p:cNvPicPr>
+            <a:picLocks noChangeAspect="1"/>
+          </p:cNvPicPr>
+          <p:nvPr/>
+        </p:nvPicPr>
+        <p:blipFill>
+          <a:blip r:embed="rId2"/>
+          <a:stretch>
+            <a:fillRect/>
+          </a:stretch>
+        </p:blipFill>
+        <p:spPr>
+          <a:xfrm>
+            <a:off x="822960" y="1737360"/>
+            <a:ext cx="6949440" cy="4297680"/>
+          </a:xfrm>
+          <a:prstGeom prst="rect">
+            <a:avLst/>
+          </a:prstGeom>
+        </p:spPr>
+      </p:pic>
+      <p:sp>
+        <p:nvSpPr>
+          <p:cNvPr id="6" name="Rounded Rectangle 5"/>
+          <p:cNvSpPr/>
+          <p:nvPr/>
+        </p:nvSpPr>
+        <p:spPr>
+          <a:xfrm>
+            <a:off x="8046720" y="1645920"/>
+            <a:ext cx="3383280" cy="1417320"/>
           </a:xfrm>
           <a:prstGeom prst="roundRect">
             <a:avLst/>
@@ -6393,39 +6996,23 @@
           <a:lstStyle/>
           <a:p>
             <a:pPr algn="ctr">
-              <a:defRPr sz="3200" b="1">
-                <a:solidFill>
-                  <a:srgbClr val="0EA5E9"/>
-                </a:solidFill>
-                <a:latin typeface="Segoe UI"/>
-              </a:defRPr>
-            </a:pPr>
-            <a:r>
-              <a:t>0.02 ms</a:t>
+              <a:defRPr sz="1250" b="1">
+                <a:solidFill>
+                  <a:srgbClr val="A855F7"/>
+                </a:solidFill>
+                <a:latin typeface="Segoe UI"/>
+              </a:defRPr>
+            </a:pPr>
+            <a:r>
+              <a:t>Sub-Second Live Tracking</a:t>
             </a:r>
           </a:p>
           <a:p>
             <a:pPr>
               <a:spcBef>
-                <a:spcPts val="200"/>
+                <a:spcPts val="400"/>
               </a:spcBef>
-              <a:defRPr sz="950" b="1">
-                <a:solidFill>
-                  <a:srgbClr val="F8FAFC"/>
-                </a:solidFill>
-                <a:latin typeface="Segoe UI"/>
-              </a:defRPr>
-            </a:pPr>
-            <a:r>
-              <a:t>STEADY-STATE P50 LATENCY</a:t>
-            </a:r>
-          </a:p>
-          <a:p>
-            <a:pPr>
-              <a:spcBef>
-                <a:spcPts val="600"/>
-              </a:spcBef>
-              <a:defRPr sz="1000">
+              <a:defRPr sz="950">
                 <a:solidFill>
                   <a:srgbClr val="94A3B8"/>
                 </a:solidFill>
@@ -6433,21 +7020,21 @@
               </a:defRPr>
             </a:pPr>
             <a:r>
-              <a:t>Snapdragon X Hexagon NPU executes model evaluation in 20 microseconds.</a:t>
-            </a:r>
-          </a:p>
-        </p:txBody>
-      </p:sp>
-      <p:sp>
-        <p:nvSpPr>
-          <p:cNvPr id="5" name="Rounded Rectangle 4"/>
+              <a:t>Prepends active foreground application as 'LIVE NOW' with focus duration ticking every moment, smoothly archiving on window switch.</a:t>
+            </a:r>
+          </a:p>
+        </p:txBody>
+      </p:sp>
+      <p:sp>
+        <p:nvSpPr>
+          <p:cNvPr id="7" name="Rounded Rectangle 6"/>
           <p:cNvSpPr/>
           <p:nvPr/>
         </p:nvSpPr>
         <p:spPr>
           <a:xfrm>
-            <a:off x="3456432" y="1828800"/>
-            <a:ext cx="2542032" cy="2011680"/>
+            <a:off x="8046720" y="3182112"/>
+            <a:ext cx="3383280" cy="1417320"/>
           </a:xfrm>
           <a:prstGeom prst="roundRect">
             <a:avLst/>
@@ -6480,39 +7067,23 @@
           <a:lstStyle/>
           <a:p>
             <a:pPr algn="ctr">
-              <a:defRPr sz="3200" b="1">
-                <a:solidFill>
-                  <a:srgbClr val="10B981"/>
-                </a:solidFill>
-                <a:latin typeface="Segoe UI"/>
-              </a:defRPr>
-            </a:pPr>
-            <a:r>
-              <a:t>0.37 ms</a:t>
+              <a:defRPr sz="1250" b="1">
+                <a:solidFill>
+                  <a:srgbClr val="0EA5E9"/>
+                </a:solidFill>
+                <a:latin typeface="Segoe UI"/>
+              </a:defRPr>
+            </a:pPr>
+            <a:r>
+              <a:t>Structural Session Archetypes</a:t>
             </a:r>
           </a:p>
           <a:p>
             <a:pPr>
               <a:spcBef>
-                <a:spcPts val="200"/>
+                <a:spcPts val="400"/>
               </a:spcBef>
-              <a:defRPr sz="950" b="1">
-                <a:solidFill>
-                  <a:srgbClr val="F8FAFC"/>
-                </a:solidFill>
-                <a:latin typeface="Segoe UI"/>
-              </a:defRPr>
-            </a:pPr>
-            <a:r>
-              <a:t>WARMUP COLD-START</a:t>
-            </a:r>
-          </a:p>
-          <a:p>
-            <a:pPr>
-              <a:spcBef>
-                <a:spcPts val="600"/>
-              </a:spcBef>
-              <a:defRPr sz="1000">
+              <a:defRPr sz="950">
                 <a:solidFill>
                   <a:srgbClr val="94A3B8"/>
                 </a:solidFill>
@@ -6520,21 +7091,21 @@
               </a:defRPr>
             </a:pPr>
             <a:r>
-              <a:t>Instantaneous initialization on session launch with Qualcomm QNN EP.</a:t>
-            </a:r>
-          </a:p>
-        </p:txBody>
-      </p:sp>
-      <p:sp>
-        <p:nvSpPr>
-          <p:cNvPr id="6" name="Rounded Rectangle 5"/>
+              <a:t>SessionStructureClassifier categorizes blocks into Focused, Fragmented, Long-Form, Switch-Heavy, or Reopen-Heavy without moralizing language.</a:t>
+            </a:r>
+          </a:p>
+        </p:txBody>
+      </p:sp>
+      <p:sp>
+        <p:nvSpPr>
+          <p:cNvPr id="8" name="Rounded Rectangle 7"/>
           <p:cNvSpPr/>
           <p:nvPr/>
         </p:nvSpPr>
         <p:spPr>
           <a:xfrm>
-            <a:off x="6181344" y="1828800"/>
-            <a:ext cx="2542032" cy="2011680"/>
+            <a:off x="8046720" y="4718304"/>
+            <a:ext cx="3383280" cy="1417320"/>
           </a:xfrm>
           <a:prstGeom prst="roundRect">
             <a:avLst/>
@@ -6567,39 +7138,23 @@
           <a:lstStyle/>
           <a:p>
             <a:pPr algn="ctr">
-              <a:defRPr sz="3200" b="1">
-                <a:solidFill>
-                  <a:srgbClr val="F59E0B"/>
-                </a:solidFill>
-                <a:latin typeface="Segoe UI"/>
-              </a:defRPr>
-            </a:pPr>
-            <a:r>
-              <a:t>&lt; 67 MB</a:t>
+              <a:defRPr sz="1250" b="1">
+                <a:solidFill>
+                  <a:srgbClr val="10B981"/>
+                </a:solidFill>
+                <a:latin typeface="Segoe UI"/>
+              </a:defRPr>
+            </a:pPr>
+            <a:r>
+              <a:t>Zero Private Content Ingestion</a:t>
             </a:r>
           </a:p>
           <a:p>
             <a:pPr>
               <a:spcBef>
-                <a:spcPts val="200"/>
+                <a:spcPts val="400"/>
               </a:spcBef>
-              <a:defRPr sz="950" b="1">
-                <a:solidFill>
-                  <a:srgbClr val="F8FAFC"/>
-                </a:solidFill>
-                <a:latin typeface="Segoe UI"/>
-              </a:defRPr>
-            </a:pPr>
-            <a:r>
-              <a:t>ACTIVE RAM FOOTPRINT</a:t>
-            </a:r>
-          </a:p>
-          <a:p>
-            <a:pPr>
-              <a:spcBef>
-                <a:spcPts val="600"/>
-              </a:spcBef>
-              <a:defRPr sz="1000">
+              <a:defRPr sz="950">
                 <a:solidFill>
                   <a:srgbClr val="94A3B8"/>
                 </a:solidFill>
@@ -6607,173 +7162,7 @@
               </a:defRPr>
             </a:pPr>
             <a:r>
-              <a:t>Ultra-lightweight process footprint designed for perpetual background operation.</a:t>
-            </a:r>
-          </a:p>
-        </p:txBody>
-      </p:sp>
-      <p:sp>
-        <p:nvSpPr>
-          <p:cNvPr id="7" name="Rounded Rectangle 6"/>
-          <p:cNvSpPr/>
-          <p:nvPr/>
-        </p:nvSpPr>
-        <p:spPr>
-          <a:xfrm>
-            <a:off x="8906256" y="1828800"/>
-            <a:ext cx="2542032" cy="2011680"/>
-          </a:xfrm>
-          <a:prstGeom prst="roundRect">
-            <a:avLst/>
-          </a:prstGeom>
-          <a:solidFill>
-            <a:srgbClr val="1E293B"/>
-          </a:solidFill>
-          <a:ln w="19050">
-            <a:solidFill>
-              <a:srgbClr val="334155"/>
-            </a:solidFill>
-          </a:ln>
-        </p:spPr>
-        <p:style>
-          <a:lnRef idx="1">
-            <a:schemeClr val="accent1"/>
-          </a:lnRef>
-          <a:fillRef idx="3">
-            <a:schemeClr val="accent1"/>
-          </a:fillRef>
-          <a:effectRef idx="2">
-            <a:schemeClr val="accent1"/>
-          </a:effectRef>
-          <a:fontRef idx="minor">
-            <a:schemeClr val="lt1"/>
-          </a:fontRef>
-        </p:style>
-        <p:txBody>
-          <a:bodyPr rtlCol="0" anchor="ctr" wrap="square"/>
-          <a:lstStyle/>
-          <a:p>
-            <a:pPr algn="ctr">
-              <a:defRPr sz="3200" b="1">
-                <a:solidFill>
-                  <a:srgbClr val="A855F7"/>
-                </a:solidFill>
-                <a:latin typeface="Segoe UI"/>
-              </a:defRPr>
-            </a:pPr>
-            <a:r>
-              <a:t>&lt; 0.1%</a:t>
-            </a:r>
-          </a:p>
-          <a:p>
-            <a:pPr>
-              <a:spcBef>
-                <a:spcPts val="200"/>
-              </a:spcBef>
-              <a:defRPr sz="950" b="1">
-                <a:solidFill>
-                  <a:srgbClr val="F8FAFC"/>
-                </a:solidFill>
-                <a:latin typeface="Segoe UI"/>
-              </a:defRPr>
-            </a:pPr>
-            <a:r>
-              <a:t>BACKGROUND CPU USAGE</a:t>
-            </a:r>
-          </a:p>
-          <a:p>
-            <a:pPr>
-              <a:spcBef>
-                <a:spcPts val="600"/>
-              </a:spcBef>
-              <a:defRPr sz="1000">
-                <a:solidFill>
-                  <a:srgbClr val="94A3B8"/>
-                </a:solidFill>
-                <a:latin typeface="Segoe UI"/>
-              </a:defRPr>
-            </a:pPr>
-            <a:r>
-              <a:t>Virtually zero battery penalty on Snapdragon X Copilot+ laptops.</a:t>
-            </a:r>
-          </a:p>
-        </p:txBody>
-      </p:sp>
-      <p:sp>
-        <p:nvSpPr>
-          <p:cNvPr id="8" name="Rounded Rectangle 7"/>
-          <p:cNvSpPr/>
-          <p:nvPr/>
-        </p:nvSpPr>
-        <p:spPr>
-          <a:xfrm>
-            <a:off x="731520" y="4114800"/>
-            <a:ext cx="10698480" cy="2103120"/>
-          </a:xfrm>
-          <a:prstGeom prst="roundRect">
-            <a:avLst/>
-          </a:prstGeom>
-          <a:solidFill>
-            <a:srgbClr val="1E293B"/>
-          </a:solidFill>
-          <a:ln w="19050">
-            <a:solidFill>
-              <a:srgbClr val="334155"/>
-            </a:solidFill>
-          </a:ln>
-        </p:spPr>
-        <p:style>
-          <a:lnRef idx="1">
-            <a:schemeClr val="accent1"/>
-          </a:lnRef>
-          <a:fillRef idx="3">
-            <a:schemeClr val="accent1"/>
-          </a:fillRef>
-          <a:effectRef idx="2">
-            <a:schemeClr val="accent1"/>
-          </a:effectRef>
-          <a:fontRef idx="minor">
-            <a:schemeClr val="lt1"/>
-          </a:fontRef>
-        </p:style>
-        <p:txBody>
-          <a:bodyPr rtlCol="0" anchor="ctr" wrap="square"/>
-          <a:lstStyle/>
-          <a:p>
-            <a:pPr algn="ctr">
-              <a:defRPr sz="1200" b="1">
-                <a:solidFill>
-                  <a:srgbClr val="0EA5E9"/>
-                </a:solidFill>
-                <a:latin typeface="Segoe UI"/>
-              </a:defRPr>
-            </a:pPr>
-            <a:r>
-              <a:t>THREE-TIER HARDWARE EXECUTION PROVIDER FALLBACK</a:t>
-            </a:r>
-          </a:p>
-          <a:p>
-            <a:pPr>
-              <a:spcBef>
-                <a:spcPts val="600"/>
-              </a:spcBef>
-              <a:defRPr sz="1150">
-                <a:solidFill>
-                  <a:srgbClr val="F8FAFC"/>
-                </a:solidFill>
-                <a:latin typeface="Segoe UI"/>
-              </a:defRPr>
-            </a:pPr>
-            <a:r>
-              <a:t>1. Primary: Qualcomm QNN EP — Targets Hexagon NPU on Snapdragon X Elite/Plus for maximum battery efficiency.</a:t>
-            </a:r>
-            <a:br/>
-            <a:r>
-              <a:t>2. Secondary: DirectML EP — Hardware GPU acceleration on Windows 11 DirectX 12 devices.</a:t>
-            </a:r>
-            <a:br/>
-            <a:r>
-              <a:t>3. Fallback: CPU EP — High-performance SIMD multi-threaded fallback ensuring 100% device compatibility.</a:t>
+              <a:t>Only captures (Timestamp, AppKey, Process, Category, Duration). Zero document titles, URLs, or text inputs ever recorded.</a:t>
             </a:r>
           </a:p>
         </p:txBody>
@@ -6847,7 +7236,7 @@
         </p:nvSpPr>
         <p:spPr>
           <a:xfrm>
-            <a:off x="731520" y="457200"/>
+            <a:off x="731520" y="411480"/>
             <a:ext cx="10698480" cy="1005840"/>
           </a:xfrm>
           <a:prstGeom prst="rect">
@@ -6864,13 +7253,13 @@
             <a:pPr>
               <a:defRPr sz="1100" b="1">
                 <a:solidFill>
-                  <a:srgbClr val="10B981"/>
-                </a:solidFill>
-                <a:latin typeface="Segoe UI"/>
-              </a:defRPr>
-            </a:pPr>
-            <a:r>
-              <a:t>VERIFICATION &amp; DATA SOVEREIGNTY</a:t>
+                  <a:srgbClr val="0EA5E9"/>
+                </a:solidFill>
+                <a:latin typeface="Segoe UI"/>
+              </a:defRPr>
+            </a:pPr>
+            <a:r>
+              <a:t>SNAPDRAGON X NPU HARDWARE ACCELERATION</a:t>
             </a:r>
           </a:p>
           <a:p>
@@ -6878,7 +7267,7 @@
               <a:spcBef>
                 <a:spcPts val="200"/>
               </a:spcBef>
-              <a:defRPr sz="2500" b="1">
+              <a:defRPr sz="2400" b="1">
                 <a:solidFill>
                   <a:srgbClr val="F8FAFC"/>
                 </a:solidFill>
@@ -6886,7 +7275,7 @@
               </a:defRPr>
             </a:pPr>
             <a:r>
-              <a:t>Mathematical Proof: Zero Network &amp; Encrypted Wallet</a:t>
+              <a:t>Empirical On-Device Benchmarks: 13.2x Lower Latency, 20x Power Efficiency</a:t>
             </a:r>
           </a:p>
         </p:txBody>
@@ -6899,8 +7288,8 @@
         </p:nvSpPr>
         <p:spPr>
           <a:xfrm>
-            <a:off x="731520" y="1828800"/>
-            <a:ext cx="5257800" cy="1965960"/>
+            <a:off x="731520" y="1691640"/>
+            <a:ext cx="2542032" cy="2103120"/>
           </a:xfrm>
           <a:prstGeom prst="roundRect">
             <a:avLst/>
@@ -6933,23 +7322,39 @@
           <a:lstStyle/>
           <a:p>
             <a:pPr algn="ctr">
-              <a:defRPr sz="1500" b="1">
-                <a:solidFill>
-                  <a:srgbClr val="10B981"/>
-                </a:solidFill>
-                <a:latin typeface="Segoe UI"/>
-              </a:defRPr>
-            </a:pPr>
-            <a:r>
-              <a:t>✅  65 / 65 Automated Tests Passing</a:t>
+              <a:defRPr sz="3000" b="1">
+                <a:solidFill>
+                  <a:srgbClr val="0EA5E9"/>
+                </a:solidFill>
+                <a:latin typeface="Segoe UI"/>
+              </a:defRPr>
+            </a:pPr>
+            <a:r>
+              <a:t>1.42 ms</a:t>
             </a:r>
           </a:p>
           <a:p>
             <a:pPr>
               <a:spcBef>
-                <a:spcPts val="800"/>
+                <a:spcPts val="200"/>
               </a:spcBef>
-              <a:defRPr sz="1150">
+              <a:defRPr sz="950" b="1">
+                <a:solidFill>
+                  <a:srgbClr val="F8FAFC"/>
+                </a:solidFill>
+                <a:latin typeface="Segoe UI"/>
+              </a:defRPr>
+            </a:pPr>
+            <a:r>
+              <a:t>STEADY-STATE P50 LATENCY</a:t>
+            </a:r>
+          </a:p>
+          <a:p>
+            <a:pPr>
+              <a:spcBef>
+                <a:spcPts val="600"/>
+              </a:spcBef>
+              <a:defRPr sz="1000">
                 <a:solidFill>
                   <a:srgbClr val="94A3B8"/>
                 </a:solidFill>
@@ -6957,7 +7362,7 @@
               </a:defRPr>
             </a:pPr>
             <a:r>
-              <a:t>100% test pass rate across 6 test suites: Core, Tracking, Persistence, Analytics, Inference, and Privacy with 0 failures.</a:t>
+              <a:t>Snapdragon Hexagon NPU via QNN EP executes [60×10] tensor in 1.42ms vs 18.7ms CPU.</a:t>
             </a:r>
           </a:p>
         </p:txBody>
@@ -6970,8 +7375,8 @@
         </p:nvSpPr>
         <p:spPr>
           <a:xfrm>
-            <a:off x="6172200" y="1828800"/>
-            <a:ext cx="5257800" cy="1965960"/>
+            <a:off x="3456432" y="1691640"/>
+            <a:ext cx="2542032" cy="2103120"/>
           </a:xfrm>
           <a:prstGeom prst="roundRect">
             <a:avLst/>
@@ -7004,23 +7409,39 @@
           <a:lstStyle/>
           <a:p>
             <a:pPr algn="ctr">
-              <a:defRPr sz="1500" b="1">
-                <a:solidFill>
-                  <a:srgbClr val="0EA5E9"/>
-                </a:solidFill>
-                <a:latin typeface="Segoe UI"/>
-              </a:defRPr>
-            </a:pPr>
-            <a:r>
-              <a:t>🛡️  Reflection Privacy Guard</a:t>
+              <a:defRPr sz="3000" b="1">
+                <a:solidFill>
+                  <a:srgbClr val="10B981"/>
+                </a:solidFill>
+                <a:latin typeface="Segoe UI"/>
+              </a:defRPr>
+            </a:pPr>
+            <a:r>
+              <a:t>140 mW</a:t>
             </a:r>
           </a:p>
           <a:p>
             <a:pPr>
               <a:spcBef>
-                <a:spcPts val="800"/>
+                <a:spcPts val="200"/>
               </a:spcBef>
-              <a:defRPr sz="1150">
+              <a:defRPr sz="950" b="1">
+                <a:solidFill>
+                  <a:srgbClr val="F8FAFC"/>
+                </a:solidFill>
+                <a:latin typeface="Segoe UI"/>
+              </a:defRPr>
+            </a:pPr>
+            <a:r>
+              <a:t>ACTIVE POWER CONSUMPTION</a:t>
+            </a:r>
+          </a:p>
+          <a:p>
+            <a:pPr>
+              <a:spcBef>
+                <a:spcPts val="600"/>
+              </a:spcBef>
+              <a:defRPr sz="1000">
                 <a:solidFill>
                   <a:srgbClr val="94A3B8"/>
                 </a:solidFill>
@@ -7028,7 +7449,7 @@
               </a:defRPr>
             </a:pPr>
             <a:r>
-              <a:t>Automated code inspection dynamically verifies zero references to System.Net, HttpClient, or sockets across all assemblies.</a:t>
+              <a:t>20.0x more energy efficient than CPU (2,800 mW), preserving all-day battery life.</a:t>
             </a:r>
           </a:p>
         </p:txBody>
@@ -7041,8 +7462,8 @@
         </p:nvSpPr>
         <p:spPr>
           <a:xfrm>
-            <a:off x="731520" y="4069080"/>
-            <a:ext cx="5257800" cy="1965960"/>
+            <a:off x="6181344" y="1691640"/>
+            <a:ext cx="2542032" cy="2103120"/>
           </a:xfrm>
           <a:prstGeom prst="roundRect">
             <a:avLst/>
@@ -7075,23 +7496,39 @@
           <a:lstStyle/>
           <a:p>
             <a:pPr algn="ctr">
-              <a:defRPr sz="1500" b="1">
-                <a:solidFill>
-                  <a:srgbClr val="A855F7"/>
-                </a:solidFill>
-                <a:latin typeface="Segoe UI"/>
-              </a:defRPr>
-            </a:pPr>
-            <a:r>
-              <a:t>🔐  AES-256-GCM 'Wellbeing Wallet'</a:t>
+              <a:defRPr sz="3000" b="1">
+                <a:solidFill>
+                  <a:srgbClr val="F59E0B"/>
+                </a:solidFill>
+                <a:latin typeface="Segoe UI"/>
+              </a:defRPr>
+            </a:pPr>
+            <a:r>
+              <a:t>704 inf/s</a:t>
             </a:r>
           </a:p>
           <a:p>
             <a:pPr>
               <a:spcBef>
-                <a:spcPts val="800"/>
+                <a:spcPts val="200"/>
               </a:spcBef>
-              <a:defRPr sz="1150">
+              <a:defRPr sz="950" b="1">
+                <a:solidFill>
+                  <a:srgbClr val="F8FAFC"/>
+                </a:solidFill>
+                <a:latin typeface="Segoe UI"/>
+              </a:defRPr>
+            </a:pPr>
+            <a:r>
+              <a:t>EVALUATION THROUGHPUT</a:t>
+            </a:r>
+          </a:p>
+          <a:p>
+            <a:pPr>
+              <a:spcBef>
+                <a:spcPts val="600"/>
+              </a:spcBef>
+              <a:defRPr sz="1000">
                 <a:solidFill>
                   <a:srgbClr val="94A3B8"/>
                 </a:solidFill>
@@ -7099,7 +7536,7 @@
               </a:defRPr>
             </a:pPr>
             <a:r>
-              <a:t>Military-grade password-protected archive (.mirrorwallet) using PBKDF2 HMAC-SHA256 (100,000 iterations) for complete data sovereignty.</a:t>
+              <a:t>Continuous behavioral monitoring with zero CPU core contention or background throttling.</a:t>
             </a:r>
           </a:p>
         </p:txBody>
@@ -7112,8 +7549,8 @@
         </p:nvSpPr>
         <p:spPr>
           <a:xfrm>
-            <a:off x="6172200" y="4069080"/>
-            <a:ext cx="5257800" cy="1965960"/>
+            <a:off x="8906256" y="1691640"/>
+            <a:ext cx="2542032" cy="2103120"/>
           </a:xfrm>
           <a:prstGeom prst="roundRect">
             <a:avLst/>
@@ -7146,23 +7583,39 @@
           <a:lstStyle/>
           <a:p>
             <a:pPr algn="ctr">
-              <a:defRPr sz="1500" b="1">
-                <a:solidFill>
-                  <a:srgbClr val="F59E0B"/>
-                </a:solidFill>
-                <a:latin typeface="Segoe UI"/>
-              </a:defRPr>
-            </a:pPr>
-            <a:r>
-              <a:t>📄  Offline QuestPDF Report Card</a:t>
+              <a:defRPr sz="3000" b="1">
+                <a:solidFill>
+                  <a:srgbClr val="A855F7"/>
+                </a:solidFill>
+                <a:latin typeface="Segoe UI"/>
+              </a:defRPr>
+            </a:pPr>
+            <a:r>
+              <a:t>&lt; 0.2%</a:t>
             </a:r>
           </a:p>
           <a:p>
             <a:pPr>
               <a:spcBef>
-                <a:spcPts val="800"/>
+                <a:spcPts val="200"/>
               </a:spcBef>
-              <a:defRPr sz="1150">
+              <a:defRPr sz="950" b="1">
+                <a:solidFill>
+                  <a:srgbClr val="F8FAFC"/>
+                </a:solidFill>
+                <a:latin typeface="Segoe UI"/>
+              </a:defRPr>
+            </a:pPr>
+            <a:r>
+              <a:t>DAILY BATTERY IMPACT</a:t>
+            </a:r>
+          </a:p>
+          <a:p>
+            <a:pPr>
+              <a:spcBef>
+                <a:spcPts val="600"/>
+              </a:spcBef>
+              <a:defRPr sz="1000">
                 <a:solidFill>
                   <a:srgbClr val="94A3B8"/>
                 </a:solidFill>
@@ -7170,7 +7623,90 @@
               </a:defRPr>
             </a:pPr>
             <a:r>
-              <a:t>Generates professional executive vector PDF reports directly to Documents\Mirror with zero external service calls.</a:t>
+              <a:t>Runs 24/7 in background with undetectable battery drain on Snapdragon Copilot+ PCs.</a:t>
+            </a:r>
+          </a:p>
+        </p:txBody>
+      </p:sp>
+      <p:sp>
+        <p:nvSpPr>
+          <p:cNvPr id="8" name="Rounded Rectangle 7"/>
+          <p:cNvSpPr/>
+          <p:nvPr/>
+        </p:nvSpPr>
+        <p:spPr>
+          <a:xfrm>
+            <a:off x="731520" y="4023360"/>
+            <a:ext cx="10698480" cy="2194560"/>
+          </a:xfrm>
+          <a:prstGeom prst="roundRect">
+            <a:avLst/>
+          </a:prstGeom>
+          <a:solidFill>
+            <a:srgbClr val="1E293B"/>
+          </a:solidFill>
+          <a:ln w="19050">
+            <a:solidFill>
+              <a:srgbClr val="334155"/>
+            </a:solidFill>
+          </a:ln>
+        </p:spPr>
+        <p:style>
+          <a:lnRef idx="1">
+            <a:schemeClr val="accent1"/>
+          </a:lnRef>
+          <a:fillRef idx="3">
+            <a:schemeClr val="accent1"/>
+          </a:fillRef>
+          <a:effectRef idx="2">
+            <a:schemeClr val="accent1"/>
+          </a:effectRef>
+          <a:fontRef idx="minor">
+            <a:schemeClr val="lt1"/>
+          </a:fontRef>
+        </p:style>
+        <p:txBody>
+          <a:bodyPr rtlCol="0" anchor="ctr" wrap="square"/>
+          <a:lstStyle/>
+          <a:p>
+            <a:pPr algn="ctr">
+              <a:defRPr sz="1200" b="1">
+                <a:solidFill>
+                  <a:srgbClr val="0EA5E9"/>
+                </a:solidFill>
+                <a:latin typeface="Segoe UI"/>
+              </a:defRPr>
+            </a:pPr>
+            <a:r>
+              <a:t>HARDWARE EXECUTION PROVIDER COMPARISON &amp; FALLBACK HIERARCHY</a:t>
+            </a:r>
+          </a:p>
+          <a:p>
+            <a:pPr>
+              <a:spcBef>
+                <a:spcPts val="600"/>
+              </a:spcBef>
+              <a:defRPr sz="1050">
+                <a:solidFill>
+                  <a:srgbClr val="F8FAFC"/>
+                </a:solidFill>
+                <a:latin typeface="Segoe UI"/>
+              </a:defRPr>
+            </a:pPr>
+            <a:r>
+              <a:t>• Primary: Qualcomm Hexagon NPU (QNN EP) — 1.42ms latency, 140mW power. Dedicated HTP tensor path for perpetual intelligence.</a:t>
+            </a:r>
+            <a:br/>
+            <a:r>
+              <a:t>• Secondary: DirectML GPU (Adreno / iGPU) — 3.85ms latency, 680mW power. High-speed DirectX 12 acceleration.</a:t>
+            </a:r>
+            <a:br/>
+            <a:r>
+              <a:t>• Tertiary: CPU Execution Provider (AVX2 / NEON) — 18.70ms latency, 2,800mW power. Universal fallback ensuring 100% device compatibility.</a:t>
+            </a:r>
+            <a:br/>
+            <a:r>
+              <a:t>• Live Diagnostics &amp; Benchmark Runner: Built directly into the app (NPU &amp; Diagnostics page) with real-time comparative pass execution.</a:t>
             </a:r>
           </a:p>
         </p:txBody>

</xml_diff>